<commit_message>
Adding a new Pattern "EARS pattern for DTS Requirements Engineering" within the RECP
</commit_message>
<xml_diff>
--- a/recp/PatternsRECPLevelData/PatternsDiagramImages/MockRECP/Patterns_Images_Project.pptx
+++ b/recp/PatternsRECPLevelData/PatternsDiagramImages/MockRECP/Patterns_Images_Project.pptx
@@ -7,6 +7,8 @@
   <p:sldIdLst>
     <p:sldId id="256" r:id="rId2"/>
     <p:sldId id="257" r:id="rId3"/>
+    <p:sldId id="258" r:id="rId4"/>
+    <p:sldId id="259" r:id="rId5"/>
   </p:sldIdLst>
   <p:sldSz cx="12192000" cy="6858000"/>
   <p:notesSz cx="6858000" cy="9144000"/>
@@ -105,6 +107,11 @@
       </a:defRPr>
     </a:lvl9pPr>
   </p:defaultTextStyle>
+  <p:extLst>
+    <p:ext uri="{EFAFB233-063F-42B5-8137-9DF3F51BA10A}">
+      <p15:sldGuideLst xmlns:p15="http://schemas.microsoft.com/office/powerpoint/2012/main"/>
+    </p:ext>
+  </p:extLst>
 </p:presentation>
 </file>
 
@@ -255,7 +262,7 @@
           <a:p>
             <a:fld id="{145C27BA-B253-496D-A458-8E48DAC590A4}" type="datetimeFigureOut">
               <a:rPr lang="fr-FR" smtClean="0"/>
-              <a:t>26/01/2026</a:t>
+              <a:t>27/01/2026</a:t>
             </a:fld>
             <a:endParaRPr lang="fr-FR"/>
           </a:p>
@@ -453,7 +460,7 @@
           <a:p>
             <a:fld id="{145C27BA-B253-496D-A458-8E48DAC590A4}" type="datetimeFigureOut">
               <a:rPr lang="fr-FR" smtClean="0"/>
-              <a:t>26/01/2026</a:t>
+              <a:t>27/01/2026</a:t>
             </a:fld>
             <a:endParaRPr lang="fr-FR"/>
           </a:p>
@@ -661,7 +668,7 @@
           <a:p>
             <a:fld id="{145C27BA-B253-496D-A458-8E48DAC590A4}" type="datetimeFigureOut">
               <a:rPr lang="fr-FR" smtClean="0"/>
-              <a:t>26/01/2026</a:t>
+              <a:t>27/01/2026</a:t>
             </a:fld>
             <a:endParaRPr lang="fr-FR"/>
           </a:p>
@@ -859,7 +866,7 @@
           <a:p>
             <a:fld id="{145C27BA-B253-496D-A458-8E48DAC590A4}" type="datetimeFigureOut">
               <a:rPr lang="fr-FR" smtClean="0"/>
-              <a:t>26/01/2026</a:t>
+              <a:t>27/01/2026</a:t>
             </a:fld>
             <a:endParaRPr lang="fr-FR"/>
           </a:p>
@@ -1134,7 +1141,7 @@
           <a:p>
             <a:fld id="{145C27BA-B253-496D-A458-8E48DAC590A4}" type="datetimeFigureOut">
               <a:rPr lang="fr-FR" smtClean="0"/>
-              <a:t>26/01/2026</a:t>
+              <a:t>27/01/2026</a:t>
             </a:fld>
             <a:endParaRPr lang="fr-FR"/>
           </a:p>
@@ -1399,7 +1406,7 @@
           <a:p>
             <a:fld id="{145C27BA-B253-496D-A458-8E48DAC590A4}" type="datetimeFigureOut">
               <a:rPr lang="fr-FR" smtClean="0"/>
-              <a:t>26/01/2026</a:t>
+              <a:t>27/01/2026</a:t>
             </a:fld>
             <a:endParaRPr lang="fr-FR"/>
           </a:p>
@@ -1811,7 +1818,7 @@
           <a:p>
             <a:fld id="{145C27BA-B253-496D-A458-8E48DAC590A4}" type="datetimeFigureOut">
               <a:rPr lang="fr-FR" smtClean="0"/>
-              <a:t>26/01/2026</a:t>
+              <a:t>27/01/2026</a:t>
             </a:fld>
             <a:endParaRPr lang="fr-FR"/>
           </a:p>
@@ -1952,7 +1959,7 @@
           <a:p>
             <a:fld id="{145C27BA-B253-496D-A458-8E48DAC590A4}" type="datetimeFigureOut">
               <a:rPr lang="fr-FR" smtClean="0"/>
-              <a:t>26/01/2026</a:t>
+              <a:t>27/01/2026</a:t>
             </a:fld>
             <a:endParaRPr lang="fr-FR"/>
           </a:p>
@@ -2065,7 +2072,7 @@
           <a:p>
             <a:fld id="{145C27BA-B253-496D-A458-8E48DAC590A4}" type="datetimeFigureOut">
               <a:rPr lang="fr-FR" smtClean="0"/>
-              <a:t>26/01/2026</a:t>
+              <a:t>27/01/2026</a:t>
             </a:fld>
             <a:endParaRPr lang="fr-FR"/>
           </a:p>
@@ -2376,7 +2383,7 @@
           <a:p>
             <a:fld id="{145C27BA-B253-496D-A458-8E48DAC590A4}" type="datetimeFigureOut">
               <a:rPr lang="fr-FR" smtClean="0"/>
-              <a:t>26/01/2026</a:t>
+              <a:t>27/01/2026</a:t>
             </a:fld>
             <a:endParaRPr lang="fr-FR"/>
           </a:p>
@@ -2664,7 +2671,7 @@
           <a:p>
             <a:fld id="{145C27BA-B253-496D-A458-8E48DAC590A4}" type="datetimeFigureOut">
               <a:rPr lang="fr-FR" smtClean="0"/>
-              <a:t>26/01/2026</a:t>
+              <a:t>27/01/2026</a:t>
             </a:fld>
             <a:endParaRPr lang="fr-FR"/>
           </a:p>
@@ -2905,7 +2912,7 @@
           <a:p>
             <a:fld id="{145C27BA-B253-496D-A458-8E48DAC590A4}" type="datetimeFigureOut">
               <a:rPr lang="fr-FR" smtClean="0"/>
-              <a:t>26/01/2026</a:t>
+              <a:t>27/01/2026</a:t>
             </a:fld>
             <a:endParaRPr lang="fr-FR"/>
           </a:p>
@@ -3890,20 +3897,8 @@
           <a:p>
             <a:pPr algn="ctr"/>
             <a:r>
-              <a:rPr lang="fr-FR" b="1" i="1" dirty="0" err="1"/>
-              <a:t>After</a:t>
-            </a:r>
-            <a:r>
               <a:rPr lang="fr-FR" b="1" i="1" dirty="0"/>
-              <a:t> </a:t>
-            </a:r>
-            <a:r>
-              <a:rPr lang="fr-FR" b="1" i="1" dirty="0" err="1"/>
-              <a:t>applying</a:t>
-            </a:r>
-            <a:r>
-              <a:rPr lang="fr-FR" b="1" i="1" dirty="0"/>
-              <a:t> </a:t>
+              <a:t>After applying </a:t>
             </a:r>
             <a:r>
               <a:rPr lang="fr-FR" b="1" i="1" dirty="0" err="1"/>
@@ -4782,20 +4777,8 @@
           <a:p>
             <a:pPr algn="ctr"/>
             <a:r>
-              <a:rPr lang="fr-FR" b="1" i="1" dirty="0" err="1"/>
-              <a:t>After</a:t>
-            </a:r>
-            <a:r>
               <a:rPr lang="fr-FR" b="1" i="1" dirty="0"/>
-              <a:t> </a:t>
-            </a:r>
-            <a:r>
-              <a:rPr lang="fr-FR" b="1" i="1" dirty="0" err="1"/>
-              <a:t>applying</a:t>
-            </a:r>
-            <a:r>
-              <a:rPr lang="fr-FR" b="1" i="1" dirty="0"/>
-              <a:t> </a:t>
+              <a:t>After applying </a:t>
             </a:r>
             <a:r>
               <a:rPr lang="fr-FR" b="1" i="1" dirty="0" err="1"/>
@@ -4977,6 +4960,1366 @@
     <p:extLst>
       <p:ext uri="{BB962C8B-B14F-4D97-AF65-F5344CB8AC3E}">
         <p14:creationId xmlns:p14="http://schemas.microsoft.com/office/powerpoint/2010/main" val="1783516109"/>
+      </p:ext>
+    </p:extLst>
+  </p:cSld>
+  <p:clrMapOvr>
+    <a:masterClrMapping/>
+  </p:clrMapOvr>
+</p:sld>
+</file>
+
+<file path=ppt/slides/slide3.xml><?xml version="1.0" encoding="utf-8"?>
+<p:sld xmlns:a="http://schemas.openxmlformats.org/drawingml/2006/main" xmlns:r="http://schemas.openxmlformats.org/officeDocument/2006/relationships" xmlns:p="http://schemas.openxmlformats.org/presentationml/2006/main">
+  <p:cSld>
+    <p:spTree>
+      <p:nvGrpSpPr>
+        <p:cNvPr id="1" name="">
+          <a:extLst>
+            <a:ext uri="{FF2B5EF4-FFF2-40B4-BE49-F238E27FC236}">
+              <a16:creationId xmlns:a16="http://schemas.microsoft.com/office/drawing/2014/main" id="{77B76AB4-F530-67F6-43C8-C6ED04F14595}"/>
+            </a:ext>
+          </a:extLst>
+        </p:cNvPr>
+        <p:cNvGrpSpPr/>
+        <p:nvPr/>
+      </p:nvGrpSpPr>
+      <p:grpSpPr>
+        <a:xfrm>
+          <a:off x="0" y="0"/>
+          <a:ext cx="0" cy="0"/>
+          <a:chOff x="0" y="0"/>
+          <a:chExt cx="0" cy="0"/>
+        </a:xfrm>
+      </p:grpSpPr>
+      <p:sp>
+        <p:nvSpPr>
+          <p:cNvPr id="9" name="ZoneTexte 8">
+            <a:extLst>
+              <a:ext uri="{FF2B5EF4-FFF2-40B4-BE49-F238E27FC236}">
+                <a16:creationId xmlns:a16="http://schemas.microsoft.com/office/drawing/2014/main" id="{919C3066-0540-7C7A-300C-3DC007B136E4}"/>
+              </a:ext>
+            </a:extLst>
+          </p:cNvPr>
+          <p:cNvSpPr txBox="1"/>
+          <p:nvPr/>
+        </p:nvSpPr>
+        <p:spPr>
+          <a:xfrm>
+            <a:off x="2260238" y="1228143"/>
+            <a:ext cx="8121468" cy="646331"/>
+          </a:xfrm>
+          <a:prstGeom prst="rect">
+            <a:avLst/>
+          </a:prstGeom>
+          <a:noFill/>
+        </p:spPr>
+        <p:txBody>
+          <a:bodyPr wrap="square" rtlCol="0">
+            <a:spAutoFit/>
+          </a:bodyPr>
+          <a:lstStyle/>
+          <a:p>
+            <a:r>
+              <a:rPr lang="en-US" b="1" dirty="0"/>
+              <a:t>Non-functional stakeholder’s requirement (need) in terms of </a:t>
+            </a:r>
+            <a:r>
+              <a:rPr lang="en-US" b="1" dirty="0" err="1"/>
+              <a:t>Evolutivity</a:t>
+            </a:r>
+            <a:r>
+              <a:rPr lang="en-US" b="1" dirty="0"/>
+              <a:t> </a:t>
+            </a:r>
+            <a:r>
+              <a:rPr lang="fr-FR" b="1" dirty="0"/>
+              <a:t>:</a:t>
+            </a:r>
+          </a:p>
+          <a:p>
+            <a:r>
+              <a:rPr lang="fr-FR" dirty="0"/>
+              <a:t>«  </a:t>
+            </a:r>
+            <a:r>
+              <a:rPr lang="en-US" dirty="0"/>
+              <a:t>NNF004- All the stakeholders want the Workshop A’s DTS to be easy to evolve.</a:t>
+            </a:r>
+            <a:r>
+              <a:rPr lang="fr-FR" dirty="0"/>
+              <a:t> »</a:t>
+            </a:r>
+          </a:p>
+        </p:txBody>
+      </p:sp>
+      <p:sp>
+        <p:nvSpPr>
+          <p:cNvPr id="10" name="ZoneTexte 9">
+            <a:extLst>
+              <a:ext uri="{FF2B5EF4-FFF2-40B4-BE49-F238E27FC236}">
+                <a16:creationId xmlns:a16="http://schemas.microsoft.com/office/drawing/2014/main" id="{A1E42A4F-D336-0BAE-900B-3FCDA9590E7B}"/>
+              </a:ext>
+            </a:extLst>
+          </p:cNvPr>
+          <p:cNvSpPr txBox="1"/>
+          <p:nvPr/>
+        </p:nvSpPr>
+        <p:spPr>
+          <a:xfrm>
+            <a:off x="2353398" y="4720897"/>
+            <a:ext cx="6127088" cy="646331"/>
+          </a:xfrm>
+          <a:prstGeom prst="rect">
+            <a:avLst/>
+          </a:prstGeom>
+          <a:noFill/>
+        </p:spPr>
+        <p:txBody>
+          <a:bodyPr wrap="square" rtlCol="0">
+            <a:spAutoFit/>
+          </a:bodyPr>
+          <a:lstStyle/>
+          <a:p>
+            <a:r>
+              <a:rPr lang="en-US" b="1" dirty="0"/>
+              <a:t>Non-functional</a:t>
+            </a:r>
+            <a:r>
+              <a:rPr lang="fr-FR" b="1" dirty="0"/>
+              <a:t> </a:t>
+            </a:r>
+            <a:r>
+              <a:rPr lang="en-US" b="1" noProof="0" dirty="0"/>
+              <a:t>DTS requirement :</a:t>
+            </a:r>
+          </a:p>
+          <a:p>
+            <a:r>
+              <a:rPr lang="fr-FR" dirty="0"/>
+              <a:t>« </a:t>
+            </a:r>
+            <a:r>
+              <a:rPr lang="en-US" dirty="0"/>
+              <a:t>RNF004 –</a:t>
+            </a:r>
+            <a:r>
+              <a:rPr lang="en-US" b="1" dirty="0">
+                <a:solidFill>
+                  <a:srgbClr val="00B050"/>
+                </a:solidFill>
+              </a:rPr>
+              <a:t>The Workshop A’s DTS </a:t>
+            </a:r>
+            <a:r>
+              <a:rPr lang="en-US" b="1" dirty="0">
+                <a:solidFill>
+                  <a:srgbClr val="7030A0"/>
+                </a:solidFill>
+              </a:rPr>
+              <a:t>shall </a:t>
+            </a:r>
+            <a:r>
+              <a:rPr lang="en-US" b="1" dirty="0">
+                <a:solidFill>
+                  <a:srgbClr val="E97132"/>
+                </a:solidFill>
+              </a:rPr>
+              <a:t>be easy to evolve</a:t>
+            </a:r>
+            <a:r>
+              <a:rPr lang="fr-FR" dirty="0"/>
+              <a:t>»</a:t>
+            </a:r>
+          </a:p>
+        </p:txBody>
+      </p:sp>
+      <p:grpSp>
+        <p:nvGrpSpPr>
+          <p:cNvPr id="4" name="Groupe 3">
+            <a:extLst>
+              <a:ext uri="{FF2B5EF4-FFF2-40B4-BE49-F238E27FC236}">
+                <a16:creationId xmlns:a16="http://schemas.microsoft.com/office/drawing/2014/main" id="{B82197F4-69E8-861E-764B-2B02F7CCCD36}"/>
+              </a:ext>
+            </a:extLst>
+          </p:cNvPr>
+          <p:cNvGrpSpPr/>
+          <p:nvPr/>
+        </p:nvGrpSpPr>
+        <p:grpSpPr>
+          <a:xfrm>
+            <a:off x="3586583" y="2383577"/>
+            <a:ext cx="5913632" cy="1988992"/>
+            <a:chOff x="3586583" y="2383577"/>
+            <a:chExt cx="5913632" cy="1988992"/>
+          </a:xfrm>
+        </p:grpSpPr>
+        <p:pic>
+          <p:nvPicPr>
+            <p:cNvPr id="3" name="Image 2" descr="Une image contenant texte, capture d’écran, Police, ligne&#10;&#10;Le contenu généré par l’IA peut être incorrect.">
+              <a:extLst>
+                <a:ext uri="{FF2B5EF4-FFF2-40B4-BE49-F238E27FC236}">
+                  <a16:creationId xmlns:a16="http://schemas.microsoft.com/office/drawing/2014/main" id="{0630BA62-1641-6F7C-DB40-B8CA0955BCF8}"/>
+                </a:ext>
+              </a:extLst>
+            </p:cNvPr>
+            <p:cNvPicPr>
+              <a:picLocks noChangeAspect="1"/>
+            </p:cNvPicPr>
+            <p:nvPr/>
+          </p:nvPicPr>
+          <p:blipFill>
+            <a:blip r:embed="rId2"/>
+            <a:stretch>
+              <a:fillRect/>
+            </a:stretch>
+          </p:blipFill>
+          <p:spPr>
+            <a:xfrm>
+              <a:off x="3586583" y="2383577"/>
+              <a:ext cx="5913632" cy="1988992"/>
+            </a:xfrm>
+            <a:prstGeom prst="rect">
+              <a:avLst/>
+            </a:prstGeom>
+          </p:spPr>
+        </p:pic>
+        <p:sp>
+          <p:nvSpPr>
+            <p:cNvPr id="11" name="Ellipse 10">
+              <a:extLst>
+                <a:ext uri="{FF2B5EF4-FFF2-40B4-BE49-F238E27FC236}">
+                  <a16:creationId xmlns:a16="http://schemas.microsoft.com/office/drawing/2014/main" id="{3BF4A4FE-9998-47F6-262F-D9B4306CF0CE}"/>
+                </a:ext>
+              </a:extLst>
+            </p:cNvPr>
+            <p:cNvSpPr/>
+            <p:nvPr/>
+          </p:nvSpPr>
+          <p:spPr>
+            <a:xfrm>
+              <a:off x="3797051" y="4059959"/>
+              <a:ext cx="306040" cy="273939"/>
+            </a:xfrm>
+            <a:prstGeom prst="ellipse">
+              <a:avLst/>
+            </a:prstGeom>
+            <a:solidFill>
+              <a:schemeClr val="accent1"/>
+            </a:solidFill>
+          </p:spPr>
+          <p:style>
+            <a:lnRef idx="2">
+              <a:schemeClr val="accent1">
+                <a:shade val="15000"/>
+              </a:schemeClr>
+            </a:lnRef>
+            <a:fillRef idx="1">
+              <a:schemeClr val="accent1"/>
+            </a:fillRef>
+            <a:effectRef idx="0">
+              <a:schemeClr val="accent1"/>
+            </a:effectRef>
+            <a:fontRef idx="minor">
+              <a:schemeClr val="lt1"/>
+            </a:fontRef>
+          </p:style>
+          <p:txBody>
+            <a:bodyPr rtlCol="0" anchor="ctr"/>
+            <a:lstStyle/>
+            <a:p>
+              <a:pPr algn="ctr"/>
+              <a:endParaRPr lang="fr-FR"/>
+            </a:p>
+          </p:txBody>
+        </p:sp>
+        <p:sp>
+          <p:nvSpPr>
+            <p:cNvPr id="12" name="Ellipse 11">
+              <a:extLst>
+                <a:ext uri="{FF2B5EF4-FFF2-40B4-BE49-F238E27FC236}">
+                  <a16:creationId xmlns:a16="http://schemas.microsoft.com/office/drawing/2014/main" id="{FDC09A75-2FD7-B0F0-827B-D3B7C5E3874C}"/>
+                </a:ext>
+              </a:extLst>
+            </p:cNvPr>
+            <p:cNvSpPr/>
+            <p:nvPr/>
+          </p:nvSpPr>
+          <p:spPr>
+            <a:xfrm>
+              <a:off x="5354842" y="3952673"/>
+              <a:ext cx="306040" cy="273939"/>
+            </a:xfrm>
+            <a:prstGeom prst="ellipse">
+              <a:avLst/>
+            </a:prstGeom>
+            <a:solidFill>
+              <a:srgbClr val="C00000"/>
+            </a:solidFill>
+          </p:spPr>
+          <p:style>
+            <a:lnRef idx="2">
+              <a:schemeClr val="accent1">
+                <a:shade val="15000"/>
+              </a:schemeClr>
+            </a:lnRef>
+            <a:fillRef idx="1">
+              <a:schemeClr val="accent1"/>
+            </a:fillRef>
+            <a:effectRef idx="0">
+              <a:schemeClr val="accent1"/>
+            </a:effectRef>
+            <a:fontRef idx="minor">
+              <a:schemeClr val="lt1"/>
+            </a:fontRef>
+          </p:style>
+          <p:txBody>
+            <a:bodyPr rtlCol="0" anchor="ctr"/>
+            <a:lstStyle/>
+            <a:p>
+              <a:pPr algn="ctr"/>
+              <a:endParaRPr lang="fr-FR"/>
+            </a:p>
+          </p:txBody>
+        </p:sp>
+        <p:sp>
+          <p:nvSpPr>
+            <p:cNvPr id="13" name="Ellipse 12">
+              <a:extLst>
+                <a:ext uri="{FF2B5EF4-FFF2-40B4-BE49-F238E27FC236}">
+                  <a16:creationId xmlns:a16="http://schemas.microsoft.com/office/drawing/2014/main" id="{AEF01D27-B1C6-8BC6-E82F-C15E9621137A}"/>
+                </a:ext>
+              </a:extLst>
+            </p:cNvPr>
+            <p:cNvSpPr/>
+            <p:nvPr/>
+          </p:nvSpPr>
+          <p:spPr>
+            <a:xfrm>
+              <a:off x="7123101" y="3735620"/>
+              <a:ext cx="306040" cy="273939"/>
+            </a:xfrm>
+            <a:prstGeom prst="ellipse">
+              <a:avLst/>
+            </a:prstGeom>
+            <a:solidFill>
+              <a:srgbClr val="00B050"/>
+            </a:solidFill>
+          </p:spPr>
+          <p:style>
+            <a:lnRef idx="2">
+              <a:schemeClr val="accent1">
+                <a:shade val="15000"/>
+              </a:schemeClr>
+            </a:lnRef>
+            <a:fillRef idx="1">
+              <a:schemeClr val="accent1"/>
+            </a:fillRef>
+            <a:effectRef idx="0">
+              <a:schemeClr val="accent1"/>
+            </a:effectRef>
+            <a:fontRef idx="minor">
+              <a:schemeClr val="lt1"/>
+            </a:fontRef>
+          </p:style>
+          <p:txBody>
+            <a:bodyPr rtlCol="0" anchor="ctr"/>
+            <a:lstStyle/>
+            <a:p>
+              <a:pPr algn="ctr"/>
+              <a:endParaRPr lang="fr-FR"/>
+            </a:p>
+          </p:txBody>
+        </p:sp>
+        <p:sp>
+          <p:nvSpPr>
+            <p:cNvPr id="14" name="Ellipse 13">
+              <a:extLst>
+                <a:ext uri="{FF2B5EF4-FFF2-40B4-BE49-F238E27FC236}">
+                  <a16:creationId xmlns:a16="http://schemas.microsoft.com/office/drawing/2014/main" id="{288B91A0-0231-EF64-141F-305626FD306B}"/>
+                </a:ext>
+              </a:extLst>
+            </p:cNvPr>
+            <p:cNvSpPr/>
+            <p:nvPr/>
+          </p:nvSpPr>
+          <p:spPr>
+            <a:xfrm>
+              <a:off x="8055574" y="3587219"/>
+              <a:ext cx="306040" cy="273939"/>
+            </a:xfrm>
+            <a:prstGeom prst="ellipse">
+              <a:avLst/>
+            </a:prstGeom>
+            <a:solidFill>
+              <a:srgbClr val="7030A0"/>
+            </a:solidFill>
+          </p:spPr>
+          <p:style>
+            <a:lnRef idx="2">
+              <a:schemeClr val="accent1">
+                <a:shade val="15000"/>
+              </a:schemeClr>
+            </a:lnRef>
+            <a:fillRef idx="1">
+              <a:schemeClr val="accent1"/>
+            </a:fillRef>
+            <a:effectRef idx="0">
+              <a:schemeClr val="accent1"/>
+            </a:effectRef>
+            <a:fontRef idx="minor">
+              <a:schemeClr val="lt1"/>
+            </a:fontRef>
+          </p:style>
+          <p:txBody>
+            <a:bodyPr rtlCol="0" anchor="ctr"/>
+            <a:lstStyle/>
+            <a:p>
+              <a:pPr algn="ctr"/>
+              <a:endParaRPr lang="fr-FR"/>
+            </a:p>
+          </p:txBody>
+        </p:sp>
+        <p:sp>
+          <p:nvSpPr>
+            <p:cNvPr id="15" name="Ellipse 14">
+              <a:extLst>
+                <a:ext uri="{FF2B5EF4-FFF2-40B4-BE49-F238E27FC236}">
+                  <a16:creationId xmlns:a16="http://schemas.microsoft.com/office/drawing/2014/main" id="{F9B56F8C-47F9-D203-0607-54371F6D147F}"/>
+                </a:ext>
+              </a:extLst>
+            </p:cNvPr>
+            <p:cNvSpPr/>
+            <p:nvPr/>
+          </p:nvSpPr>
+          <p:spPr>
+            <a:xfrm>
+              <a:off x="8924797" y="3724188"/>
+              <a:ext cx="306040" cy="273939"/>
+            </a:xfrm>
+            <a:prstGeom prst="ellipse">
+              <a:avLst/>
+            </a:prstGeom>
+            <a:solidFill>
+              <a:schemeClr val="accent2"/>
+            </a:solidFill>
+          </p:spPr>
+          <p:style>
+            <a:lnRef idx="2">
+              <a:schemeClr val="accent1">
+                <a:shade val="15000"/>
+              </a:schemeClr>
+            </a:lnRef>
+            <a:fillRef idx="1">
+              <a:schemeClr val="accent1"/>
+            </a:fillRef>
+            <a:effectRef idx="0">
+              <a:schemeClr val="accent1"/>
+            </a:effectRef>
+            <a:fontRef idx="minor">
+              <a:schemeClr val="lt1"/>
+            </a:fontRef>
+          </p:style>
+          <p:txBody>
+            <a:bodyPr rtlCol="0" anchor="ctr"/>
+            <a:lstStyle/>
+            <a:p>
+              <a:pPr algn="ctr"/>
+              <a:endParaRPr lang="fr-FR"/>
+            </a:p>
+          </p:txBody>
+        </p:sp>
+      </p:grpSp>
+      <p:sp>
+        <p:nvSpPr>
+          <p:cNvPr id="17" name="Flèche : bas 16">
+            <a:extLst>
+              <a:ext uri="{FF2B5EF4-FFF2-40B4-BE49-F238E27FC236}">
+                <a16:creationId xmlns:a16="http://schemas.microsoft.com/office/drawing/2014/main" id="{67DD141B-F6E7-9675-C6AE-FF74E9A71358}"/>
+              </a:ext>
+            </a:extLst>
+          </p:cNvPr>
+          <p:cNvSpPr/>
+          <p:nvPr/>
+        </p:nvSpPr>
+        <p:spPr>
+          <a:xfrm>
+            <a:off x="2927235" y="2572666"/>
+            <a:ext cx="275771" cy="2109410"/>
+          </a:xfrm>
+          <a:prstGeom prst="downArrow">
+            <a:avLst/>
+          </a:prstGeom>
+        </p:spPr>
+        <p:style>
+          <a:lnRef idx="2">
+            <a:schemeClr val="dk1">
+              <a:shade val="15000"/>
+            </a:schemeClr>
+          </a:lnRef>
+          <a:fillRef idx="1">
+            <a:schemeClr val="dk1"/>
+          </a:fillRef>
+          <a:effectRef idx="0">
+            <a:schemeClr val="dk1"/>
+          </a:effectRef>
+          <a:fontRef idx="minor">
+            <a:schemeClr val="lt1"/>
+          </a:fontRef>
+        </p:style>
+        <p:txBody>
+          <a:bodyPr rtlCol="0" anchor="ctr"/>
+          <a:lstStyle/>
+          <a:p>
+            <a:pPr algn="ctr"/>
+            <a:endParaRPr lang="fr-FR"/>
+          </a:p>
+        </p:txBody>
+      </p:sp>
+      <p:sp>
+        <p:nvSpPr>
+          <p:cNvPr id="18" name="ZoneTexte 17">
+            <a:extLst>
+              <a:ext uri="{FF2B5EF4-FFF2-40B4-BE49-F238E27FC236}">
+                <a16:creationId xmlns:a16="http://schemas.microsoft.com/office/drawing/2014/main" id="{05820A4D-134A-BAEC-E36B-74138A4CB2DD}"/>
+              </a:ext>
+            </a:extLst>
+          </p:cNvPr>
+          <p:cNvSpPr txBox="1"/>
+          <p:nvPr/>
+        </p:nvSpPr>
+        <p:spPr>
+          <a:xfrm>
+            <a:off x="939901" y="3226259"/>
+            <a:ext cx="2070705" cy="646331"/>
+          </a:xfrm>
+          <a:prstGeom prst="rect">
+            <a:avLst/>
+          </a:prstGeom>
+          <a:noFill/>
+        </p:spPr>
+        <p:txBody>
+          <a:bodyPr wrap="square" rtlCol="0">
+            <a:spAutoFit/>
+          </a:bodyPr>
+          <a:lstStyle/>
+          <a:p>
+            <a:pPr algn="ctr"/>
+            <a:r>
+              <a:rPr lang="en-US" b="1" i="1" noProof="0" dirty="0"/>
+              <a:t>After applying EARS’ boilerplate</a:t>
+            </a:r>
+          </a:p>
+        </p:txBody>
+      </p:sp>
+      <p:sp>
+        <p:nvSpPr>
+          <p:cNvPr id="20" name="Rectangle 19">
+            <a:extLst>
+              <a:ext uri="{FF2B5EF4-FFF2-40B4-BE49-F238E27FC236}">
+                <a16:creationId xmlns:a16="http://schemas.microsoft.com/office/drawing/2014/main" id="{0CF7C952-7409-79C8-F8F7-166CE74C6FB8}"/>
+              </a:ext>
+            </a:extLst>
+          </p:cNvPr>
+          <p:cNvSpPr/>
+          <p:nvPr/>
+        </p:nvSpPr>
+        <p:spPr>
+          <a:xfrm>
+            <a:off x="2035266" y="1084451"/>
+            <a:ext cx="8346440" cy="1236793"/>
+          </a:xfrm>
+          <a:prstGeom prst="rect">
+            <a:avLst/>
+          </a:prstGeom>
+          <a:noFill/>
+          <a:ln w="9525" cap="flat" cmpd="sng" algn="ctr">
+            <a:solidFill>
+              <a:schemeClr val="dk1"/>
+            </a:solidFill>
+            <a:prstDash val="solid"/>
+            <a:round/>
+            <a:headEnd type="none" w="med" len="med"/>
+            <a:tailEnd type="none" w="med" len="med"/>
+          </a:ln>
+        </p:spPr>
+        <p:style>
+          <a:lnRef idx="0">
+            <a:scrgbClr r="0" g="0" b="0"/>
+          </a:lnRef>
+          <a:fillRef idx="0">
+            <a:scrgbClr r="0" g="0" b="0"/>
+          </a:fillRef>
+          <a:effectRef idx="0">
+            <a:scrgbClr r="0" g="0" b="0"/>
+          </a:effectRef>
+          <a:fontRef idx="minor">
+            <a:schemeClr val="dk1"/>
+          </a:fontRef>
+        </p:style>
+        <p:txBody>
+          <a:bodyPr rtlCol="0" anchor="ctr"/>
+          <a:lstStyle/>
+          <a:p>
+            <a:pPr algn="ctr"/>
+            <a:endParaRPr lang="fr-FR"/>
+          </a:p>
+        </p:txBody>
+      </p:sp>
+      <p:sp>
+        <p:nvSpPr>
+          <p:cNvPr id="21" name="Rectangle 20">
+            <a:extLst>
+              <a:ext uri="{FF2B5EF4-FFF2-40B4-BE49-F238E27FC236}">
+                <a16:creationId xmlns:a16="http://schemas.microsoft.com/office/drawing/2014/main" id="{6C9B13BD-26FA-FF13-F0B9-274984A2F276}"/>
+              </a:ext>
+            </a:extLst>
+          </p:cNvPr>
+          <p:cNvSpPr/>
+          <p:nvPr/>
+        </p:nvSpPr>
+        <p:spPr>
+          <a:xfrm>
+            <a:off x="2054141" y="4743206"/>
+            <a:ext cx="6307473" cy="942736"/>
+          </a:xfrm>
+          <a:prstGeom prst="rect">
+            <a:avLst/>
+          </a:prstGeom>
+          <a:noFill/>
+          <a:ln w="9525" cap="flat" cmpd="sng" algn="ctr">
+            <a:solidFill>
+              <a:schemeClr val="dk1"/>
+            </a:solidFill>
+            <a:prstDash val="solid"/>
+            <a:round/>
+            <a:headEnd type="none" w="med" len="med"/>
+            <a:tailEnd type="none" w="med" len="med"/>
+          </a:ln>
+        </p:spPr>
+        <p:style>
+          <a:lnRef idx="0">
+            <a:scrgbClr r="0" g="0" b="0"/>
+          </a:lnRef>
+          <a:fillRef idx="0">
+            <a:scrgbClr r="0" g="0" b="0"/>
+          </a:fillRef>
+          <a:effectRef idx="0">
+            <a:scrgbClr r="0" g="0" b="0"/>
+          </a:effectRef>
+          <a:fontRef idx="minor">
+            <a:schemeClr val="dk1"/>
+          </a:fontRef>
+        </p:style>
+        <p:txBody>
+          <a:bodyPr rtlCol="0" anchor="ctr"/>
+          <a:lstStyle/>
+          <a:p>
+            <a:pPr algn="ctr"/>
+            <a:endParaRPr lang="fr-FR"/>
+          </a:p>
+        </p:txBody>
+      </p:sp>
+    </p:spTree>
+    <p:extLst>
+      <p:ext uri="{BB962C8B-B14F-4D97-AF65-F5344CB8AC3E}">
+        <p14:creationId xmlns:p14="http://schemas.microsoft.com/office/powerpoint/2010/main" val="4152668966"/>
+      </p:ext>
+    </p:extLst>
+  </p:cSld>
+  <p:clrMapOvr>
+    <a:masterClrMapping/>
+  </p:clrMapOvr>
+</p:sld>
+</file>
+
+<file path=ppt/slides/slide4.xml><?xml version="1.0" encoding="utf-8"?>
+<p:sld xmlns:a="http://schemas.openxmlformats.org/drawingml/2006/main" xmlns:r="http://schemas.openxmlformats.org/officeDocument/2006/relationships" xmlns:p="http://schemas.openxmlformats.org/presentationml/2006/main">
+  <p:cSld>
+    <p:spTree>
+      <p:nvGrpSpPr>
+        <p:cNvPr id="1" name="">
+          <a:extLst>
+            <a:ext uri="{FF2B5EF4-FFF2-40B4-BE49-F238E27FC236}">
+              <a16:creationId xmlns:a16="http://schemas.microsoft.com/office/drawing/2014/main" id="{1A47CA0B-17D5-1F26-C165-EBB01FB568CC}"/>
+            </a:ext>
+          </a:extLst>
+        </p:cNvPr>
+        <p:cNvGrpSpPr/>
+        <p:nvPr/>
+      </p:nvGrpSpPr>
+      <p:grpSpPr>
+        <a:xfrm>
+          <a:off x="0" y="0"/>
+          <a:ext cx="0" cy="0"/>
+          <a:chOff x="0" y="0"/>
+          <a:chExt cx="0" cy="0"/>
+        </a:xfrm>
+      </p:grpSpPr>
+      <p:sp>
+        <p:nvSpPr>
+          <p:cNvPr id="9" name="ZoneTexte 8">
+            <a:extLst>
+              <a:ext uri="{FF2B5EF4-FFF2-40B4-BE49-F238E27FC236}">
+                <a16:creationId xmlns:a16="http://schemas.microsoft.com/office/drawing/2014/main" id="{7C2211EE-8808-6BC7-86EF-A32A37CC30F9}"/>
+              </a:ext>
+            </a:extLst>
+          </p:cNvPr>
+          <p:cNvSpPr txBox="1"/>
+          <p:nvPr/>
+        </p:nvSpPr>
+        <p:spPr>
+          <a:xfrm>
+            <a:off x="1104493" y="826644"/>
+            <a:ext cx="9829800" cy="1477328"/>
+          </a:xfrm>
+          <a:prstGeom prst="rect">
+            <a:avLst/>
+          </a:prstGeom>
+          <a:noFill/>
+        </p:spPr>
+        <p:txBody>
+          <a:bodyPr wrap="square" rtlCol="0">
+            <a:spAutoFit/>
+          </a:bodyPr>
+          <a:lstStyle/>
+          <a:p>
+            <a:r>
+              <a:rPr lang="en-US" b="1" dirty="0"/>
+              <a:t>Operational stakeholder’s requirement (need) in terms of Installation/Deployment/Delivery /Configuration</a:t>
+            </a:r>
+            <a:r>
+              <a:rPr lang="fr-FR" b="1" dirty="0"/>
+              <a:t>:</a:t>
+            </a:r>
+          </a:p>
+          <a:p>
+            <a:r>
+              <a:rPr lang="fr-FR" dirty="0"/>
+              <a:t>«  </a:t>
+            </a:r>
+            <a:r>
+              <a:rPr lang="en-US" dirty="0"/>
+              <a:t>NO001- The Company wants any version of any Modeling &amp; Simulation’s sub-project composing the Workshop A’s DTS to be stored and accessible for any update-related modifications within a repository</a:t>
+            </a:r>
+            <a:r>
+              <a:rPr lang="fr-FR" dirty="0"/>
+              <a:t>»</a:t>
+            </a:r>
+          </a:p>
+        </p:txBody>
+      </p:sp>
+      <p:sp>
+        <p:nvSpPr>
+          <p:cNvPr id="10" name="ZoneTexte 9">
+            <a:extLst>
+              <a:ext uri="{FF2B5EF4-FFF2-40B4-BE49-F238E27FC236}">
+                <a16:creationId xmlns:a16="http://schemas.microsoft.com/office/drawing/2014/main" id="{1E65F532-A3F9-5B17-DEE7-E1C353637FC0}"/>
+              </a:ext>
+            </a:extLst>
+          </p:cNvPr>
+          <p:cNvSpPr txBox="1"/>
+          <p:nvPr/>
+        </p:nvSpPr>
+        <p:spPr>
+          <a:xfrm>
+            <a:off x="1386280" y="4861229"/>
+            <a:ext cx="9736429" cy="1200329"/>
+          </a:xfrm>
+          <a:prstGeom prst="rect">
+            <a:avLst/>
+          </a:prstGeom>
+          <a:noFill/>
+        </p:spPr>
+        <p:txBody>
+          <a:bodyPr wrap="square" rtlCol="0">
+            <a:spAutoFit/>
+          </a:bodyPr>
+          <a:lstStyle/>
+          <a:p>
+            <a:r>
+              <a:rPr lang="en-US" b="1" noProof="0" dirty="0"/>
+              <a:t>Operational DTS requirement </a:t>
+            </a:r>
+            <a:r>
+              <a:rPr lang="en-US" b="1" dirty="0"/>
+              <a:t>in terms of Installation/Deployment/Delivery/Configuration</a:t>
+            </a:r>
+            <a:r>
+              <a:rPr lang="fr-FR" b="1" dirty="0"/>
+              <a:t>:</a:t>
+            </a:r>
+          </a:p>
+          <a:p>
+            <a:r>
+              <a:rPr lang="fr-FR" dirty="0"/>
+              <a:t>« </a:t>
+            </a:r>
+            <a:r>
+              <a:rPr lang="en-US" dirty="0"/>
+              <a:t>RO001 –</a:t>
+            </a:r>
+            <a:r>
+              <a:rPr lang="en-US" b="1" dirty="0">
+                <a:solidFill>
+                  <a:srgbClr val="156082"/>
+                </a:solidFill>
+              </a:rPr>
+              <a:t>While</a:t>
+            </a:r>
+            <a:r>
+              <a:rPr lang="en-US" b="1" dirty="0">
+                <a:solidFill>
+                  <a:srgbClr val="00B050"/>
+                </a:solidFill>
+              </a:rPr>
+              <a:t> </a:t>
+            </a:r>
+            <a:r>
+              <a:rPr lang="en-US" b="1" dirty="0">
+                <a:solidFill>
+                  <a:srgbClr val="C00000"/>
+                </a:solidFill>
+              </a:rPr>
+              <a:t>the Workshop A’s DTS is deployed, delivered and configured,</a:t>
+            </a:r>
+            <a:r>
+              <a:rPr lang="en-US" b="1" dirty="0">
+                <a:solidFill>
+                  <a:srgbClr val="00B050"/>
+                </a:solidFill>
+              </a:rPr>
+              <a:t> any Workshop A’s DTS’ version of any Modeling &amp; Simulation’s sub-project composing it </a:t>
+            </a:r>
+            <a:r>
+              <a:rPr lang="en-US" b="1" dirty="0">
+                <a:solidFill>
+                  <a:srgbClr val="7030A0"/>
+                </a:solidFill>
+              </a:rPr>
+              <a:t>shall</a:t>
+            </a:r>
+            <a:r>
+              <a:rPr lang="en-US" b="1" dirty="0">
+                <a:solidFill>
+                  <a:srgbClr val="00B050"/>
+                </a:solidFill>
+              </a:rPr>
+              <a:t> </a:t>
+            </a:r>
+            <a:r>
+              <a:rPr lang="en-US" b="1" dirty="0">
+                <a:solidFill>
+                  <a:srgbClr val="E97132"/>
+                </a:solidFill>
+              </a:rPr>
+              <a:t>be stored and accessible for any update-related modifications within a central repository</a:t>
+            </a:r>
+            <a:r>
+              <a:rPr lang="en-US" b="1" dirty="0">
+                <a:solidFill>
+                  <a:srgbClr val="00B050"/>
+                </a:solidFill>
+              </a:rPr>
+              <a:t> </a:t>
+            </a:r>
+            <a:r>
+              <a:rPr lang="fr-FR" dirty="0"/>
+              <a:t>»</a:t>
+            </a:r>
+          </a:p>
+        </p:txBody>
+      </p:sp>
+      <p:grpSp>
+        <p:nvGrpSpPr>
+          <p:cNvPr id="2" name="Groupe 1">
+            <a:extLst>
+              <a:ext uri="{FF2B5EF4-FFF2-40B4-BE49-F238E27FC236}">
+                <a16:creationId xmlns:a16="http://schemas.microsoft.com/office/drawing/2014/main" id="{5690CE38-0A83-E846-EC91-F0D1990B3544}"/>
+              </a:ext>
+            </a:extLst>
+          </p:cNvPr>
+          <p:cNvGrpSpPr/>
+          <p:nvPr/>
+        </p:nvGrpSpPr>
+        <p:grpSpPr>
+          <a:xfrm>
+            <a:off x="3586583" y="2383577"/>
+            <a:ext cx="5913632" cy="1988992"/>
+            <a:chOff x="3586583" y="2383577"/>
+            <a:chExt cx="5913632" cy="1988992"/>
+          </a:xfrm>
+        </p:grpSpPr>
+        <p:pic>
+          <p:nvPicPr>
+            <p:cNvPr id="3" name="Image 2" descr="Une image contenant texte, capture d’écran, Police, ligne&#10;&#10;Le contenu généré par l’IA peut être incorrect.">
+              <a:extLst>
+                <a:ext uri="{FF2B5EF4-FFF2-40B4-BE49-F238E27FC236}">
+                  <a16:creationId xmlns:a16="http://schemas.microsoft.com/office/drawing/2014/main" id="{16BB42BD-78EA-EC38-5711-273EB9164FA6}"/>
+                </a:ext>
+              </a:extLst>
+            </p:cNvPr>
+            <p:cNvPicPr>
+              <a:picLocks noChangeAspect="1"/>
+            </p:cNvPicPr>
+            <p:nvPr/>
+          </p:nvPicPr>
+          <p:blipFill>
+            <a:blip r:embed="rId2"/>
+            <a:stretch>
+              <a:fillRect/>
+            </a:stretch>
+          </p:blipFill>
+          <p:spPr>
+            <a:xfrm>
+              <a:off x="3586583" y="2383577"/>
+              <a:ext cx="5913632" cy="1988992"/>
+            </a:xfrm>
+            <a:prstGeom prst="rect">
+              <a:avLst/>
+            </a:prstGeom>
+          </p:spPr>
+        </p:pic>
+        <p:sp>
+          <p:nvSpPr>
+            <p:cNvPr id="11" name="Ellipse 10">
+              <a:extLst>
+                <a:ext uri="{FF2B5EF4-FFF2-40B4-BE49-F238E27FC236}">
+                  <a16:creationId xmlns:a16="http://schemas.microsoft.com/office/drawing/2014/main" id="{0316822D-7623-B463-4F59-D828FC135590}"/>
+                </a:ext>
+              </a:extLst>
+            </p:cNvPr>
+            <p:cNvSpPr/>
+            <p:nvPr/>
+          </p:nvSpPr>
+          <p:spPr>
+            <a:xfrm>
+              <a:off x="3797051" y="4059959"/>
+              <a:ext cx="306040" cy="273939"/>
+            </a:xfrm>
+            <a:prstGeom prst="ellipse">
+              <a:avLst/>
+            </a:prstGeom>
+            <a:solidFill>
+              <a:schemeClr val="accent1"/>
+            </a:solidFill>
+          </p:spPr>
+          <p:style>
+            <a:lnRef idx="2">
+              <a:schemeClr val="accent1">
+                <a:shade val="15000"/>
+              </a:schemeClr>
+            </a:lnRef>
+            <a:fillRef idx="1">
+              <a:schemeClr val="accent1"/>
+            </a:fillRef>
+            <a:effectRef idx="0">
+              <a:schemeClr val="accent1"/>
+            </a:effectRef>
+            <a:fontRef idx="minor">
+              <a:schemeClr val="lt1"/>
+            </a:fontRef>
+          </p:style>
+          <p:txBody>
+            <a:bodyPr rtlCol="0" anchor="ctr"/>
+            <a:lstStyle/>
+            <a:p>
+              <a:pPr algn="ctr"/>
+              <a:endParaRPr lang="fr-FR"/>
+            </a:p>
+          </p:txBody>
+        </p:sp>
+        <p:sp>
+          <p:nvSpPr>
+            <p:cNvPr id="12" name="Ellipse 11">
+              <a:extLst>
+                <a:ext uri="{FF2B5EF4-FFF2-40B4-BE49-F238E27FC236}">
+                  <a16:creationId xmlns:a16="http://schemas.microsoft.com/office/drawing/2014/main" id="{76833F5B-A248-26DB-E72F-DC4D4CA37EE4}"/>
+                </a:ext>
+              </a:extLst>
+            </p:cNvPr>
+            <p:cNvSpPr/>
+            <p:nvPr/>
+          </p:nvSpPr>
+          <p:spPr>
+            <a:xfrm>
+              <a:off x="5354842" y="3952673"/>
+              <a:ext cx="306040" cy="273939"/>
+            </a:xfrm>
+            <a:prstGeom prst="ellipse">
+              <a:avLst/>
+            </a:prstGeom>
+            <a:solidFill>
+              <a:srgbClr val="C00000"/>
+            </a:solidFill>
+          </p:spPr>
+          <p:style>
+            <a:lnRef idx="2">
+              <a:schemeClr val="accent1">
+                <a:shade val="15000"/>
+              </a:schemeClr>
+            </a:lnRef>
+            <a:fillRef idx="1">
+              <a:schemeClr val="accent1"/>
+            </a:fillRef>
+            <a:effectRef idx="0">
+              <a:schemeClr val="accent1"/>
+            </a:effectRef>
+            <a:fontRef idx="minor">
+              <a:schemeClr val="lt1"/>
+            </a:fontRef>
+          </p:style>
+          <p:txBody>
+            <a:bodyPr rtlCol="0" anchor="ctr"/>
+            <a:lstStyle/>
+            <a:p>
+              <a:pPr algn="ctr"/>
+              <a:endParaRPr lang="fr-FR"/>
+            </a:p>
+          </p:txBody>
+        </p:sp>
+        <p:sp>
+          <p:nvSpPr>
+            <p:cNvPr id="13" name="Ellipse 12">
+              <a:extLst>
+                <a:ext uri="{FF2B5EF4-FFF2-40B4-BE49-F238E27FC236}">
+                  <a16:creationId xmlns:a16="http://schemas.microsoft.com/office/drawing/2014/main" id="{225EE748-1B69-4F8C-74C5-90A7D4F54503}"/>
+                </a:ext>
+              </a:extLst>
+            </p:cNvPr>
+            <p:cNvSpPr/>
+            <p:nvPr/>
+          </p:nvSpPr>
+          <p:spPr>
+            <a:xfrm>
+              <a:off x="7123101" y="3735620"/>
+              <a:ext cx="306040" cy="273939"/>
+            </a:xfrm>
+            <a:prstGeom prst="ellipse">
+              <a:avLst/>
+            </a:prstGeom>
+            <a:solidFill>
+              <a:srgbClr val="00B050"/>
+            </a:solidFill>
+          </p:spPr>
+          <p:style>
+            <a:lnRef idx="2">
+              <a:schemeClr val="accent1">
+                <a:shade val="15000"/>
+              </a:schemeClr>
+            </a:lnRef>
+            <a:fillRef idx="1">
+              <a:schemeClr val="accent1"/>
+            </a:fillRef>
+            <a:effectRef idx="0">
+              <a:schemeClr val="accent1"/>
+            </a:effectRef>
+            <a:fontRef idx="minor">
+              <a:schemeClr val="lt1"/>
+            </a:fontRef>
+          </p:style>
+          <p:txBody>
+            <a:bodyPr rtlCol="0" anchor="ctr"/>
+            <a:lstStyle/>
+            <a:p>
+              <a:pPr algn="ctr"/>
+              <a:endParaRPr lang="fr-FR"/>
+            </a:p>
+          </p:txBody>
+        </p:sp>
+        <p:sp>
+          <p:nvSpPr>
+            <p:cNvPr id="14" name="Ellipse 13">
+              <a:extLst>
+                <a:ext uri="{FF2B5EF4-FFF2-40B4-BE49-F238E27FC236}">
+                  <a16:creationId xmlns:a16="http://schemas.microsoft.com/office/drawing/2014/main" id="{C90962C6-7B16-71AE-64CC-8C8090880CA3}"/>
+                </a:ext>
+              </a:extLst>
+            </p:cNvPr>
+            <p:cNvSpPr/>
+            <p:nvPr/>
+          </p:nvSpPr>
+          <p:spPr>
+            <a:xfrm>
+              <a:off x="8055574" y="3587219"/>
+              <a:ext cx="306040" cy="273939"/>
+            </a:xfrm>
+            <a:prstGeom prst="ellipse">
+              <a:avLst/>
+            </a:prstGeom>
+            <a:solidFill>
+              <a:srgbClr val="7030A0"/>
+            </a:solidFill>
+          </p:spPr>
+          <p:style>
+            <a:lnRef idx="2">
+              <a:schemeClr val="accent1">
+                <a:shade val="15000"/>
+              </a:schemeClr>
+            </a:lnRef>
+            <a:fillRef idx="1">
+              <a:schemeClr val="accent1"/>
+            </a:fillRef>
+            <a:effectRef idx="0">
+              <a:schemeClr val="accent1"/>
+            </a:effectRef>
+            <a:fontRef idx="minor">
+              <a:schemeClr val="lt1"/>
+            </a:fontRef>
+          </p:style>
+          <p:txBody>
+            <a:bodyPr rtlCol="0" anchor="ctr"/>
+            <a:lstStyle/>
+            <a:p>
+              <a:pPr algn="ctr"/>
+              <a:endParaRPr lang="fr-FR"/>
+            </a:p>
+          </p:txBody>
+        </p:sp>
+        <p:sp>
+          <p:nvSpPr>
+            <p:cNvPr id="15" name="Ellipse 14">
+              <a:extLst>
+                <a:ext uri="{FF2B5EF4-FFF2-40B4-BE49-F238E27FC236}">
+                  <a16:creationId xmlns:a16="http://schemas.microsoft.com/office/drawing/2014/main" id="{8C236252-FBEE-4EC0-8229-F9038BCBC04A}"/>
+                </a:ext>
+              </a:extLst>
+            </p:cNvPr>
+            <p:cNvSpPr/>
+            <p:nvPr/>
+          </p:nvSpPr>
+          <p:spPr>
+            <a:xfrm>
+              <a:off x="8924797" y="3724188"/>
+              <a:ext cx="306040" cy="273939"/>
+            </a:xfrm>
+            <a:prstGeom prst="ellipse">
+              <a:avLst/>
+            </a:prstGeom>
+            <a:solidFill>
+              <a:schemeClr val="accent2"/>
+            </a:solidFill>
+          </p:spPr>
+          <p:style>
+            <a:lnRef idx="2">
+              <a:schemeClr val="accent1">
+                <a:shade val="15000"/>
+              </a:schemeClr>
+            </a:lnRef>
+            <a:fillRef idx="1">
+              <a:schemeClr val="accent1"/>
+            </a:fillRef>
+            <a:effectRef idx="0">
+              <a:schemeClr val="accent1"/>
+            </a:effectRef>
+            <a:fontRef idx="minor">
+              <a:schemeClr val="lt1"/>
+            </a:fontRef>
+          </p:style>
+          <p:txBody>
+            <a:bodyPr rtlCol="0" anchor="ctr"/>
+            <a:lstStyle/>
+            <a:p>
+              <a:pPr algn="ctr"/>
+              <a:endParaRPr lang="fr-FR"/>
+            </a:p>
+          </p:txBody>
+        </p:sp>
+      </p:grpSp>
+      <p:sp>
+        <p:nvSpPr>
+          <p:cNvPr id="17" name="Flèche : bas 16">
+            <a:extLst>
+              <a:ext uri="{FF2B5EF4-FFF2-40B4-BE49-F238E27FC236}">
+                <a16:creationId xmlns:a16="http://schemas.microsoft.com/office/drawing/2014/main" id="{2C28D489-9FF9-5F21-EC99-113A693BCBB6}"/>
+              </a:ext>
+            </a:extLst>
+          </p:cNvPr>
+          <p:cNvSpPr/>
+          <p:nvPr/>
+        </p:nvSpPr>
+        <p:spPr>
+          <a:xfrm>
+            <a:off x="2927235" y="2572666"/>
+            <a:ext cx="275771" cy="2109410"/>
+          </a:xfrm>
+          <a:prstGeom prst="downArrow">
+            <a:avLst/>
+          </a:prstGeom>
+        </p:spPr>
+        <p:style>
+          <a:lnRef idx="2">
+            <a:schemeClr val="dk1">
+              <a:shade val="15000"/>
+            </a:schemeClr>
+          </a:lnRef>
+          <a:fillRef idx="1">
+            <a:schemeClr val="dk1"/>
+          </a:fillRef>
+          <a:effectRef idx="0">
+            <a:schemeClr val="dk1"/>
+          </a:effectRef>
+          <a:fontRef idx="minor">
+            <a:schemeClr val="lt1"/>
+          </a:fontRef>
+        </p:style>
+        <p:txBody>
+          <a:bodyPr rtlCol="0" anchor="ctr"/>
+          <a:lstStyle/>
+          <a:p>
+            <a:pPr algn="ctr"/>
+            <a:endParaRPr lang="fr-FR"/>
+          </a:p>
+        </p:txBody>
+      </p:sp>
+      <p:sp>
+        <p:nvSpPr>
+          <p:cNvPr id="18" name="ZoneTexte 17">
+            <a:extLst>
+              <a:ext uri="{FF2B5EF4-FFF2-40B4-BE49-F238E27FC236}">
+                <a16:creationId xmlns:a16="http://schemas.microsoft.com/office/drawing/2014/main" id="{DDAF7D18-20F7-4507-C439-1463D1F85074}"/>
+              </a:ext>
+            </a:extLst>
+          </p:cNvPr>
+          <p:cNvSpPr txBox="1"/>
+          <p:nvPr/>
+        </p:nvSpPr>
+        <p:spPr>
+          <a:xfrm>
+            <a:off x="939901" y="3226259"/>
+            <a:ext cx="2070705" cy="646331"/>
+          </a:xfrm>
+          <a:prstGeom prst="rect">
+            <a:avLst/>
+          </a:prstGeom>
+          <a:noFill/>
+        </p:spPr>
+        <p:txBody>
+          <a:bodyPr wrap="square" rtlCol="0">
+            <a:spAutoFit/>
+          </a:bodyPr>
+          <a:lstStyle/>
+          <a:p>
+            <a:pPr algn="ctr"/>
+            <a:r>
+              <a:rPr lang="en-US" b="1" i="1" noProof="0" dirty="0"/>
+              <a:t>After applying EARS’ boilerplate</a:t>
+            </a:r>
+          </a:p>
+        </p:txBody>
+      </p:sp>
+      <p:sp>
+        <p:nvSpPr>
+          <p:cNvPr id="20" name="Rectangle 19">
+            <a:extLst>
+              <a:ext uri="{FF2B5EF4-FFF2-40B4-BE49-F238E27FC236}">
+                <a16:creationId xmlns:a16="http://schemas.microsoft.com/office/drawing/2014/main" id="{0A08488E-4870-CDF2-91F7-09B81EED65B9}"/>
+              </a:ext>
+            </a:extLst>
+          </p:cNvPr>
+          <p:cNvSpPr/>
+          <p:nvPr/>
+        </p:nvSpPr>
+        <p:spPr>
+          <a:xfrm>
+            <a:off x="939901" y="682952"/>
+            <a:ext cx="10250424" cy="1554668"/>
+          </a:xfrm>
+          <a:prstGeom prst="rect">
+            <a:avLst/>
+          </a:prstGeom>
+          <a:noFill/>
+          <a:ln w="9525" cap="flat" cmpd="sng" algn="ctr">
+            <a:solidFill>
+              <a:schemeClr val="dk1"/>
+            </a:solidFill>
+            <a:prstDash val="solid"/>
+            <a:round/>
+            <a:headEnd type="none" w="med" len="med"/>
+            <a:tailEnd type="none" w="med" len="med"/>
+          </a:ln>
+        </p:spPr>
+        <p:style>
+          <a:lnRef idx="0">
+            <a:scrgbClr r="0" g="0" b="0"/>
+          </a:lnRef>
+          <a:fillRef idx="0">
+            <a:scrgbClr r="0" g="0" b="0"/>
+          </a:fillRef>
+          <a:effectRef idx="0">
+            <a:scrgbClr r="0" g="0" b="0"/>
+          </a:effectRef>
+          <a:fontRef idx="minor">
+            <a:schemeClr val="dk1"/>
+          </a:fontRef>
+        </p:style>
+        <p:txBody>
+          <a:bodyPr rtlCol="0" anchor="ctr"/>
+          <a:lstStyle/>
+          <a:p>
+            <a:pPr algn="ctr"/>
+            <a:endParaRPr lang="fr-FR"/>
+          </a:p>
+        </p:txBody>
+      </p:sp>
+      <p:sp>
+        <p:nvSpPr>
+          <p:cNvPr id="21" name="Rectangle 20">
+            <a:extLst>
+              <a:ext uri="{FF2B5EF4-FFF2-40B4-BE49-F238E27FC236}">
+                <a16:creationId xmlns:a16="http://schemas.microsoft.com/office/drawing/2014/main" id="{498BF576-6711-577D-4B33-CD05582BF615}"/>
+              </a:ext>
+            </a:extLst>
+          </p:cNvPr>
+          <p:cNvSpPr/>
+          <p:nvPr/>
+        </p:nvSpPr>
+        <p:spPr>
+          <a:xfrm>
+            <a:off x="1225296" y="4743206"/>
+            <a:ext cx="10058399" cy="1318352"/>
+          </a:xfrm>
+          <a:prstGeom prst="rect">
+            <a:avLst/>
+          </a:prstGeom>
+          <a:noFill/>
+          <a:ln w="9525" cap="flat" cmpd="sng" algn="ctr">
+            <a:solidFill>
+              <a:schemeClr val="dk1"/>
+            </a:solidFill>
+            <a:prstDash val="solid"/>
+            <a:round/>
+            <a:headEnd type="none" w="med" len="med"/>
+            <a:tailEnd type="none" w="med" len="med"/>
+          </a:ln>
+        </p:spPr>
+        <p:style>
+          <a:lnRef idx="0">
+            <a:scrgbClr r="0" g="0" b="0"/>
+          </a:lnRef>
+          <a:fillRef idx="0">
+            <a:scrgbClr r="0" g="0" b="0"/>
+          </a:fillRef>
+          <a:effectRef idx="0">
+            <a:scrgbClr r="0" g="0" b="0"/>
+          </a:effectRef>
+          <a:fontRef idx="minor">
+            <a:schemeClr val="dk1"/>
+          </a:fontRef>
+        </p:style>
+        <p:txBody>
+          <a:bodyPr rtlCol="0" anchor="ctr"/>
+          <a:lstStyle/>
+          <a:p>
+            <a:pPr algn="ctr"/>
+            <a:endParaRPr lang="fr-FR"/>
+          </a:p>
+        </p:txBody>
+      </p:sp>
+    </p:spTree>
+    <p:extLst>
+      <p:ext uri="{BB962C8B-B14F-4D97-AF65-F5344CB8AC3E}">
+        <p14:creationId xmlns:p14="http://schemas.microsoft.com/office/powerpoint/2010/main" val="1301469462"/>
       </p:ext>
     </p:extLst>
   </p:cSld>

</xml_diff>

<commit_message>
Adding a MQTT Architectural pattern for DTS-related systems interoperability management within the RECP
</commit_message>
<xml_diff>
--- a/recp/PatternsRECPLevelData/PatternsDiagramImages/MockRECP/Patterns_Images_Project.pptx
+++ b/recp/PatternsRECPLevelData/PatternsDiagramImages/MockRECP/Patterns_Images_Project.pptx
@@ -4,11 +4,16 @@
   <p:sldMasterIdLst>
     <p:sldMasterId id="2147483648" r:id="rId1"/>
   </p:sldMasterIdLst>
+  <p:notesMasterIdLst>
+    <p:notesMasterId r:id="rId8"/>
+  </p:notesMasterIdLst>
   <p:sldIdLst>
     <p:sldId id="256" r:id="rId2"/>
     <p:sldId id="257" r:id="rId3"/>
     <p:sldId id="258" r:id="rId4"/>
     <p:sldId id="259" r:id="rId5"/>
+    <p:sldId id="260" r:id="rId6"/>
+    <p:sldId id="261" r:id="rId7"/>
   </p:sldIdLst>
   <p:sldSz cx="12192000" cy="6858000"/>
   <p:notesSz cx="6858000" cy="9144000"/>
@@ -115,6 +120,446 @@
 </p:presentation>
 </file>
 
+<file path=ppt/notesMasters/notesMaster1.xml><?xml version="1.0" encoding="utf-8"?>
+<p:notesMaster xmlns:a="http://schemas.openxmlformats.org/drawingml/2006/main" xmlns:r="http://schemas.openxmlformats.org/officeDocument/2006/relationships" xmlns:p="http://schemas.openxmlformats.org/presentationml/2006/main">
+  <p:cSld>
+    <p:bg>
+      <p:bgRef idx="1001">
+        <a:schemeClr val="bg1"/>
+      </p:bgRef>
+    </p:bg>
+    <p:spTree>
+      <p:nvGrpSpPr>
+        <p:cNvPr id="1" name=""/>
+        <p:cNvGrpSpPr/>
+        <p:nvPr/>
+      </p:nvGrpSpPr>
+      <p:grpSpPr>
+        <a:xfrm>
+          <a:off x="0" y="0"/>
+          <a:ext cx="0" cy="0"/>
+          <a:chOff x="0" y="0"/>
+          <a:chExt cx="0" cy="0"/>
+        </a:xfrm>
+      </p:grpSpPr>
+      <p:sp>
+        <p:nvSpPr>
+          <p:cNvPr id="2" name="Espace réservé de l'en-tête 1"/>
+          <p:cNvSpPr>
+            <a:spLocks noGrp="1"/>
+          </p:cNvSpPr>
+          <p:nvPr>
+            <p:ph type="hdr" sz="quarter"/>
+          </p:nvPr>
+        </p:nvSpPr>
+        <p:spPr>
+          <a:xfrm>
+            <a:off x="0" y="0"/>
+            <a:ext cx="2971800" cy="458788"/>
+          </a:xfrm>
+          <a:prstGeom prst="rect">
+            <a:avLst/>
+          </a:prstGeom>
+        </p:spPr>
+        <p:txBody>
+          <a:bodyPr vert="horz" lIns="91440" tIns="45720" rIns="91440" bIns="45720" rtlCol="0"/>
+          <a:lstStyle>
+            <a:lvl1pPr algn="l">
+              <a:defRPr sz="1200"/>
+            </a:lvl1pPr>
+          </a:lstStyle>
+          <a:p>
+            <a:endParaRPr lang="fr-FR"/>
+          </a:p>
+        </p:txBody>
+      </p:sp>
+      <p:sp>
+        <p:nvSpPr>
+          <p:cNvPr id="3" name="Espace réservé de la date 2"/>
+          <p:cNvSpPr>
+            <a:spLocks noGrp="1"/>
+          </p:cNvSpPr>
+          <p:nvPr>
+            <p:ph type="dt" idx="1"/>
+          </p:nvPr>
+        </p:nvSpPr>
+        <p:spPr>
+          <a:xfrm>
+            <a:off x="3884613" y="0"/>
+            <a:ext cx="2971800" cy="458788"/>
+          </a:xfrm>
+          <a:prstGeom prst="rect">
+            <a:avLst/>
+          </a:prstGeom>
+        </p:spPr>
+        <p:txBody>
+          <a:bodyPr vert="horz" lIns="91440" tIns="45720" rIns="91440" bIns="45720" rtlCol="0"/>
+          <a:lstStyle>
+            <a:lvl1pPr algn="r">
+              <a:defRPr sz="1200"/>
+            </a:lvl1pPr>
+          </a:lstStyle>
+          <a:p>
+            <a:fld id="{0A1B0B78-0998-4994-BA35-AC12655997EF}" type="datetimeFigureOut">
+              <a:rPr lang="fr-FR" smtClean="0"/>
+              <a:t>28/01/2026</a:t>
+            </a:fld>
+            <a:endParaRPr lang="fr-FR"/>
+          </a:p>
+        </p:txBody>
+      </p:sp>
+      <p:sp>
+        <p:nvSpPr>
+          <p:cNvPr id="4" name="Espace réservé de l'image des diapositives 3"/>
+          <p:cNvSpPr>
+            <a:spLocks noGrp="1" noRot="1" noChangeAspect="1"/>
+          </p:cNvSpPr>
+          <p:nvPr>
+            <p:ph type="sldImg" idx="2"/>
+          </p:nvPr>
+        </p:nvSpPr>
+        <p:spPr>
+          <a:xfrm>
+            <a:off x="685800" y="1143000"/>
+            <a:ext cx="5486400" cy="3086100"/>
+          </a:xfrm>
+          <a:prstGeom prst="rect">
+            <a:avLst/>
+          </a:prstGeom>
+          <a:noFill/>
+          <a:ln w="12700">
+            <a:solidFill>
+              <a:prstClr val="black"/>
+            </a:solidFill>
+          </a:ln>
+        </p:spPr>
+        <p:txBody>
+          <a:bodyPr vert="horz" lIns="91440" tIns="45720" rIns="91440" bIns="45720" rtlCol="0" anchor="ctr"/>
+          <a:lstStyle/>
+          <a:p>
+            <a:endParaRPr lang="fr-FR"/>
+          </a:p>
+        </p:txBody>
+      </p:sp>
+      <p:sp>
+        <p:nvSpPr>
+          <p:cNvPr id="5" name="Espace réservé des notes 4"/>
+          <p:cNvSpPr>
+            <a:spLocks noGrp="1"/>
+          </p:cNvSpPr>
+          <p:nvPr>
+            <p:ph type="body" sz="quarter" idx="3"/>
+          </p:nvPr>
+        </p:nvSpPr>
+        <p:spPr>
+          <a:xfrm>
+            <a:off x="685800" y="4400550"/>
+            <a:ext cx="5486400" cy="3600450"/>
+          </a:xfrm>
+          <a:prstGeom prst="rect">
+            <a:avLst/>
+          </a:prstGeom>
+        </p:spPr>
+        <p:txBody>
+          <a:bodyPr vert="horz" lIns="91440" tIns="45720" rIns="91440" bIns="45720" rtlCol="0"/>
+          <a:lstStyle/>
+          <a:p>
+            <a:pPr lvl="0"/>
+            <a:r>
+              <a:rPr lang="fr-FR"/>
+              <a:t>Cliquez pour modifier les styles du texte du masque</a:t>
+            </a:r>
+          </a:p>
+          <a:p>
+            <a:pPr lvl="1"/>
+            <a:r>
+              <a:rPr lang="fr-FR"/>
+              <a:t>Deuxième niveau</a:t>
+            </a:r>
+          </a:p>
+          <a:p>
+            <a:pPr lvl="2"/>
+            <a:r>
+              <a:rPr lang="fr-FR"/>
+              <a:t>Troisième niveau</a:t>
+            </a:r>
+          </a:p>
+          <a:p>
+            <a:pPr lvl="3"/>
+            <a:r>
+              <a:rPr lang="fr-FR"/>
+              <a:t>Quatrième niveau</a:t>
+            </a:r>
+          </a:p>
+          <a:p>
+            <a:pPr lvl="4"/>
+            <a:r>
+              <a:rPr lang="fr-FR"/>
+              <a:t>Cinquième niveau</a:t>
+            </a:r>
+          </a:p>
+        </p:txBody>
+      </p:sp>
+      <p:sp>
+        <p:nvSpPr>
+          <p:cNvPr id="6" name="Espace réservé du pied de page 5"/>
+          <p:cNvSpPr>
+            <a:spLocks noGrp="1"/>
+          </p:cNvSpPr>
+          <p:nvPr>
+            <p:ph type="ftr" sz="quarter" idx="4"/>
+          </p:nvPr>
+        </p:nvSpPr>
+        <p:spPr>
+          <a:xfrm>
+            <a:off x="0" y="8685213"/>
+            <a:ext cx="2971800" cy="458787"/>
+          </a:xfrm>
+          <a:prstGeom prst="rect">
+            <a:avLst/>
+          </a:prstGeom>
+        </p:spPr>
+        <p:txBody>
+          <a:bodyPr vert="horz" lIns="91440" tIns="45720" rIns="91440" bIns="45720" rtlCol="0" anchor="b"/>
+          <a:lstStyle>
+            <a:lvl1pPr algn="l">
+              <a:defRPr sz="1200"/>
+            </a:lvl1pPr>
+          </a:lstStyle>
+          <a:p>
+            <a:endParaRPr lang="fr-FR"/>
+          </a:p>
+        </p:txBody>
+      </p:sp>
+      <p:sp>
+        <p:nvSpPr>
+          <p:cNvPr id="7" name="Espace réservé du numéro de diapositive 6"/>
+          <p:cNvSpPr>
+            <a:spLocks noGrp="1"/>
+          </p:cNvSpPr>
+          <p:nvPr>
+            <p:ph type="sldNum" sz="quarter" idx="5"/>
+          </p:nvPr>
+        </p:nvSpPr>
+        <p:spPr>
+          <a:xfrm>
+            <a:off x="3884613" y="8685213"/>
+            <a:ext cx="2971800" cy="458787"/>
+          </a:xfrm>
+          <a:prstGeom prst="rect">
+            <a:avLst/>
+          </a:prstGeom>
+        </p:spPr>
+        <p:txBody>
+          <a:bodyPr vert="horz" lIns="91440" tIns="45720" rIns="91440" bIns="45720" rtlCol="0" anchor="b"/>
+          <a:lstStyle>
+            <a:lvl1pPr algn="r">
+              <a:defRPr sz="1200"/>
+            </a:lvl1pPr>
+          </a:lstStyle>
+          <a:p>
+            <a:fld id="{D132DE9C-AC09-4485-BD92-8EFCDCB52345}" type="slidenum">
+              <a:rPr lang="fr-FR" smtClean="0"/>
+              <a:t>‹N°›</a:t>
+            </a:fld>
+            <a:endParaRPr lang="fr-FR"/>
+          </a:p>
+        </p:txBody>
+      </p:sp>
+    </p:spTree>
+    <p:extLst>
+      <p:ext uri="{BB962C8B-B14F-4D97-AF65-F5344CB8AC3E}">
+        <p14:creationId xmlns:p14="http://schemas.microsoft.com/office/powerpoint/2010/main" val="3600114290"/>
+      </p:ext>
+    </p:extLst>
+  </p:cSld>
+  <p:clrMap bg1="lt1" tx1="dk1" bg2="lt2" tx2="dk2" accent1="accent1" accent2="accent2" accent3="accent3" accent4="accent4" accent5="accent5" accent6="accent6" hlink="hlink" folHlink="folHlink"/>
+  <p:notesStyle>
+    <a:lvl1pPr marL="0" algn="l" defTabSz="914400" rtl="0" eaLnBrk="1" latinLnBrk="0" hangingPunct="1">
+      <a:defRPr sz="1200" kern="1200">
+        <a:solidFill>
+          <a:schemeClr val="tx1"/>
+        </a:solidFill>
+        <a:latin typeface="+mn-lt"/>
+        <a:ea typeface="+mn-ea"/>
+        <a:cs typeface="+mn-cs"/>
+      </a:defRPr>
+    </a:lvl1pPr>
+    <a:lvl2pPr marL="457200" algn="l" defTabSz="914400" rtl="0" eaLnBrk="1" latinLnBrk="0" hangingPunct="1">
+      <a:defRPr sz="1200" kern="1200">
+        <a:solidFill>
+          <a:schemeClr val="tx1"/>
+        </a:solidFill>
+        <a:latin typeface="+mn-lt"/>
+        <a:ea typeface="+mn-ea"/>
+        <a:cs typeface="+mn-cs"/>
+      </a:defRPr>
+    </a:lvl2pPr>
+    <a:lvl3pPr marL="914400" algn="l" defTabSz="914400" rtl="0" eaLnBrk="1" latinLnBrk="0" hangingPunct="1">
+      <a:defRPr sz="1200" kern="1200">
+        <a:solidFill>
+          <a:schemeClr val="tx1"/>
+        </a:solidFill>
+        <a:latin typeface="+mn-lt"/>
+        <a:ea typeface="+mn-ea"/>
+        <a:cs typeface="+mn-cs"/>
+      </a:defRPr>
+    </a:lvl3pPr>
+    <a:lvl4pPr marL="1371600" algn="l" defTabSz="914400" rtl="0" eaLnBrk="1" latinLnBrk="0" hangingPunct="1">
+      <a:defRPr sz="1200" kern="1200">
+        <a:solidFill>
+          <a:schemeClr val="tx1"/>
+        </a:solidFill>
+        <a:latin typeface="+mn-lt"/>
+        <a:ea typeface="+mn-ea"/>
+        <a:cs typeface="+mn-cs"/>
+      </a:defRPr>
+    </a:lvl4pPr>
+    <a:lvl5pPr marL="1828800" algn="l" defTabSz="914400" rtl="0" eaLnBrk="1" latinLnBrk="0" hangingPunct="1">
+      <a:defRPr sz="1200" kern="1200">
+        <a:solidFill>
+          <a:schemeClr val="tx1"/>
+        </a:solidFill>
+        <a:latin typeface="+mn-lt"/>
+        <a:ea typeface="+mn-ea"/>
+        <a:cs typeface="+mn-cs"/>
+      </a:defRPr>
+    </a:lvl5pPr>
+    <a:lvl6pPr marL="2286000" algn="l" defTabSz="914400" rtl="0" eaLnBrk="1" latinLnBrk="0" hangingPunct="1">
+      <a:defRPr sz="1200" kern="1200">
+        <a:solidFill>
+          <a:schemeClr val="tx1"/>
+        </a:solidFill>
+        <a:latin typeface="+mn-lt"/>
+        <a:ea typeface="+mn-ea"/>
+        <a:cs typeface="+mn-cs"/>
+      </a:defRPr>
+    </a:lvl6pPr>
+    <a:lvl7pPr marL="2743200" algn="l" defTabSz="914400" rtl="0" eaLnBrk="1" latinLnBrk="0" hangingPunct="1">
+      <a:defRPr sz="1200" kern="1200">
+        <a:solidFill>
+          <a:schemeClr val="tx1"/>
+        </a:solidFill>
+        <a:latin typeface="+mn-lt"/>
+        <a:ea typeface="+mn-ea"/>
+        <a:cs typeface="+mn-cs"/>
+      </a:defRPr>
+    </a:lvl7pPr>
+    <a:lvl8pPr marL="3200400" algn="l" defTabSz="914400" rtl="0" eaLnBrk="1" latinLnBrk="0" hangingPunct="1">
+      <a:defRPr sz="1200" kern="1200">
+        <a:solidFill>
+          <a:schemeClr val="tx1"/>
+        </a:solidFill>
+        <a:latin typeface="+mn-lt"/>
+        <a:ea typeface="+mn-ea"/>
+        <a:cs typeface="+mn-cs"/>
+      </a:defRPr>
+    </a:lvl8pPr>
+    <a:lvl9pPr marL="3657600" algn="l" defTabSz="914400" rtl="0" eaLnBrk="1" latinLnBrk="0" hangingPunct="1">
+      <a:defRPr sz="1200" kern="1200">
+        <a:solidFill>
+          <a:schemeClr val="tx1"/>
+        </a:solidFill>
+        <a:latin typeface="+mn-lt"/>
+        <a:ea typeface="+mn-ea"/>
+        <a:cs typeface="+mn-cs"/>
+      </a:defRPr>
+    </a:lvl9pPr>
+  </p:notesStyle>
+</p:notesMaster>
+</file>
+
+<file path=ppt/notesSlides/notesSlide1.xml><?xml version="1.0" encoding="utf-8"?>
+<p:notes xmlns:a="http://schemas.openxmlformats.org/drawingml/2006/main" xmlns:r="http://schemas.openxmlformats.org/officeDocument/2006/relationships" xmlns:p="http://schemas.openxmlformats.org/presentationml/2006/main">
+  <p:cSld>
+    <p:spTree>
+      <p:nvGrpSpPr>
+        <p:cNvPr id="1" name=""/>
+        <p:cNvGrpSpPr/>
+        <p:nvPr/>
+      </p:nvGrpSpPr>
+      <p:grpSpPr>
+        <a:xfrm>
+          <a:off x="0" y="0"/>
+          <a:ext cx="0" cy="0"/>
+          <a:chOff x="0" y="0"/>
+          <a:chExt cx="0" cy="0"/>
+        </a:xfrm>
+      </p:grpSpPr>
+      <p:sp>
+        <p:nvSpPr>
+          <p:cNvPr id="2" name="Espace réservé de l'image des diapositives 1"/>
+          <p:cNvSpPr>
+            <a:spLocks noGrp="1" noRot="1" noChangeAspect="1"/>
+          </p:cNvSpPr>
+          <p:nvPr>
+            <p:ph type="sldImg"/>
+          </p:nvPr>
+        </p:nvSpPr>
+        <p:spPr/>
+        <p:txBody>
+          <a:bodyPr/>
+          <a:lstStyle/>
+          <a:p>
+            <a:endParaRPr lang="fr-FR"/>
+          </a:p>
+        </p:txBody>
+      </p:sp>
+      <p:sp>
+        <p:nvSpPr>
+          <p:cNvPr id="3" name="Espace réservé des notes 2"/>
+          <p:cNvSpPr>
+            <a:spLocks noGrp="1"/>
+          </p:cNvSpPr>
+          <p:nvPr>
+            <p:ph type="body" idx="1"/>
+          </p:nvPr>
+        </p:nvSpPr>
+        <p:spPr/>
+        <p:txBody>
+          <a:bodyPr/>
+          <a:lstStyle/>
+          <a:p>
+            <a:endParaRPr lang="fr-FR" dirty="0"/>
+          </a:p>
+        </p:txBody>
+      </p:sp>
+      <p:sp>
+        <p:nvSpPr>
+          <p:cNvPr id="4" name="Espace réservé du numéro de diapositive 3"/>
+          <p:cNvSpPr>
+            <a:spLocks noGrp="1"/>
+          </p:cNvSpPr>
+          <p:nvPr>
+            <p:ph type="sldNum" sz="quarter" idx="5"/>
+          </p:nvPr>
+        </p:nvSpPr>
+        <p:spPr/>
+        <p:txBody>
+          <a:bodyPr/>
+          <a:lstStyle/>
+          <a:p>
+            <a:fld id="{D132DE9C-AC09-4485-BD92-8EFCDCB52345}" type="slidenum">
+              <a:rPr lang="fr-FR" smtClean="0"/>
+              <a:t>6</a:t>
+            </a:fld>
+            <a:endParaRPr lang="fr-FR"/>
+          </a:p>
+        </p:txBody>
+      </p:sp>
+    </p:spTree>
+    <p:extLst>
+      <p:ext uri="{BB962C8B-B14F-4D97-AF65-F5344CB8AC3E}">
+        <p14:creationId xmlns:p14="http://schemas.microsoft.com/office/powerpoint/2010/main" val="3060096212"/>
+      </p:ext>
+    </p:extLst>
+  </p:cSld>
+  <p:clrMapOvr>
+    <a:masterClrMapping/>
+  </p:clrMapOvr>
+</p:notes>
+</file>
+
 <file path=ppt/slideLayouts/slideLayout1.xml><?xml version="1.0" encoding="utf-8"?>
 <p:sldLayout xmlns:a="http://schemas.openxmlformats.org/drawingml/2006/main" xmlns:r="http://schemas.openxmlformats.org/officeDocument/2006/relationships" xmlns:p="http://schemas.openxmlformats.org/presentationml/2006/main" type="title" preserve="1">
   <p:cSld name="Diapositive de titre">
@@ -262,7 +707,7 @@
           <a:p>
             <a:fld id="{145C27BA-B253-496D-A458-8E48DAC590A4}" type="datetimeFigureOut">
               <a:rPr lang="fr-FR" smtClean="0"/>
-              <a:t>27/01/2026</a:t>
+              <a:t>28/01/2026</a:t>
             </a:fld>
             <a:endParaRPr lang="fr-FR"/>
           </a:p>
@@ -460,7 +905,7 @@
           <a:p>
             <a:fld id="{145C27BA-B253-496D-A458-8E48DAC590A4}" type="datetimeFigureOut">
               <a:rPr lang="fr-FR" smtClean="0"/>
-              <a:t>27/01/2026</a:t>
+              <a:t>28/01/2026</a:t>
             </a:fld>
             <a:endParaRPr lang="fr-FR"/>
           </a:p>
@@ -668,7 +1113,7 @@
           <a:p>
             <a:fld id="{145C27BA-B253-496D-A458-8E48DAC590A4}" type="datetimeFigureOut">
               <a:rPr lang="fr-FR" smtClean="0"/>
-              <a:t>27/01/2026</a:t>
+              <a:t>28/01/2026</a:t>
             </a:fld>
             <a:endParaRPr lang="fr-FR"/>
           </a:p>
@@ -866,7 +1311,7 @@
           <a:p>
             <a:fld id="{145C27BA-B253-496D-A458-8E48DAC590A4}" type="datetimeFigureOut">
               <a:rPr lang="fr-FR" smtClean="0"/>
-              <a:t>27/01/2026</a:t>
+              <a:t>28/01/2026</a:t>
             </a:fld>
             <a:endParaRPr lang="fr-FR"/>
           </a:p>
@@ -1141,7 +1586,7 @@
           <a:p>
             <a:fld id="{145C27BA-B253-496D-A458-8E48DAC590A4}" type="datetimeFigureOut">
               <a:rPr lang="fr-FR" smtClean="0"/>
-              <a:t>27/01/2026</a:t>
+              <a:t>28/01/2026</a:t>
             </a:fld>
             <a:endParaRPr lang="fr-FR"/>
           </a:p>
@@ -1406,7 +1851,7 @@
           <a:p>
             <a:fld id="{145C27BA-B253-496D-A458-8E48DAC590A4}" type="datetimeFigureOut">
               <a:rPr lang="fr-FR" smtClean="0"/>
-              <a:t>27/01/2026</a:t>
+              <a:t>28/01/2026</a:t>
             </a:fld>
             <a:endParaRPr lang="fr-FR"/>
           </a:p>
@@ -1818,7 +2263,7 @@
           <a:p>
             <a:fld id="{145C27BA-B253-496D-A458-8E48DAC590A4}" type="datetimeFigureOut">
               <a:rPr lang="fr-FR" smtClean="0"/>
-              <a:t>27/01/2026</a:t>
+              <a:t>28/01/2026</a:t>
             </a:fld>
             <a:endParaRPr lang="fr-FR"/>
           </a:p>
@@ -1959,7 +2404,7 @@
           <a:p>
             <a:fld id="{145C27BA-B253-496D-A458-8E48DAC590A4}" type="datetimeFigureOut">
               <a:rPr lang="fr-FR" smtClean="0"/>
-              <a:t>27/01/2026</a:t>
+              <a:t>28/01/2026</a:t>
             </a:fld>
             <a:endParaRPr lang="fr-FR"/>
           </a:p>
@@ -2072,7 +2517,7 @@
           <a:p>
             <a:fld id="{145C27BA-B253-496D-A458-8E48DAC590A4}" type="datetimeFigureOut">
               <a:rPr lang="fr-FR" smtClean="0"/>
-              <a:t>27/01/2026</a:t>
+              <a:t>28/01/2026</a:t>
             </a:fld>
             <a:endParaRPr lang="fr-FR"/>
           </a:p>
@@ -2383,7 +2828,7 @@
           <a:p>
             <a:fld id="{145C27BA-B253-496D-A458-8E48DAC590A4}" type="datetimeFigureOut">
               <a:rPr lang="fr-FR" smtClean="0"/>
-              <a:t>27/01/2026</a:t>
+              <a:t>28/01/2026</a:t>
             </a:fld>
             <a:endParaRPr lang="fr-FR"/>
           </a:p>
@@ -2671,7 +3116,7 @@
           <a:p>
             <a:fld id="{145C27BA-B253-496D-A458-8E48DAC590A4}" type="datetimeFigureOut">
               <a:rPr lang="fr-FR" smtClean="0"/>
-              <a:t>27/01/2026</a:t>
+              <a:t>28/01/2026</a:t>
             </a:fld>
             <a:endParaRPr lang="fr-FR"/>
           </a:p>
@@ -2912,7 +3357,7 @@
           <a:p>
             <a:fld id="{145C27BA-B253-496D-A458-8E48DAC590A4}" type="datetimeFigureOut">
               <a:rPr lang="fr-FR" smtClean="0"/>
-              <a:t>27/01/2026</a:t>
+              <a:t>28/01/2026</a:t>
             </a:fld>
             <a:endParaRPr lang="fr-FR"/>
           </a:p>
@@ -6320,6 +6765,1909 @@
     <p:extLst>
       <p:ext uri="{BB962C8B-B14F-4D97-AF65-F5344CB8AC3E}">
         <p14:creationId xmlns:p14="http://schemas.microsoft.com/office/powerpoint/2010/main" val="1301469462"/>
+      </p:ext>
+    </p:extLst>
+  </p:cSld>
+  <p:clrMapOvr>
+    <a:masterClrMapping/>
+  </p:clrMapOvr>
+</p:sld>
+</file>
+
+<file path=ppt/slides/slide5.xml><?xml version="1.0" encoding="utf-8"?>
+<p:sld xmlns:a="http://schemas.openxmlformats.org/drawingml/2006/main" xmlns:r="http://schemas.openxmlformats.org/officeDocument/2006/relationships" xmlns:p="http://schemas.openxmlformats.org/presentationml/2006/main">
+  <p:cSld>
+    <p:spTree>
+      <p:nvGrpSpPr>
+        <p:cNvPr id="1" name="">
+          <a:extLst>
+            <a:ext uri="{FF2B5EF4-FFF2-40B4-BE49-F238E27FC236}">
+              <a16:creationId xmlns:a16="http://schemas.microsoft.com/office/drawing/2014/main" id="{AE665187-71AF-C7E9-2201-F0D8118B7A69}"/>
+            </a:ext>
+          </a:extLst>
+        </p:cNvPr>
+        <p:cNvGrpSpPr/>
+        <p:nvPr/>
+      </p:nvGrpSpPr>
+      <p:grpSpPr>
+        <a:xfrm>
+          <a:off x="0" y="0"/>
+          <a:ext cx="0" cy="0"/>
+          <a:chOff x="0" y="0"/>
+          <a:chExt cx="0" cy="0"/>
+        </a:xfrm>
+      </p:grpSpPr>
+      <p:pic>
+        <p:nvPicPr>
+          <p:cNvPr id="3" name="Image 2" descr="Une image contenant texte, diagramme, Plan, capture d’écran&#10;&#10;Le contenu généré par l’IA peut être incorrect.">
+            <a:extLst>
+              <a:ext uri="{FF2B5EF4-FFF2-40B4-BE49-F238E27FC236}">
+                <a16:creationId xmlns:a16="http://schemas.microsoft.com/office/drawing/2014/main" id="{F971A19D-E55D-C164-F6C2-E581E2363E26}"/>
+              </a:ext>
+            </a:extLst>
+          </p:cNvPr>
+          <p:cNvPicPr>
+            <a:picLocks noChangeAspect="1"/>
+          </p:cNvPicPr>
+          <p:nvPr/>
+        </p:nvPicPr>
+        <p:blipFill>
+          <a:blip r:embed="rId2">
+            <a:extLst>
+              <a:ext uri="{28A0092B-C50C-407E-A947-70E740481C1C}">
+                <a14:useLocalDpi xmlns:a14="http://schemas.microsoft.com/office/drawing/2010/main" val="0"/>
+              </a:ext>
+            </a:extLst>
+          </a:blip>
+          <a:stretch>
+            <a:fillRect/>
+          </a:stretch>
+        </p:blipFill>
+        <p:spPr>
+          <a:xfrm>
+            <a:off x="1797432" y="150122"/>
+            <a:ext cx="9144127" cy="6270775"/>
+          </a:xfrm>
+          <a:prstGeom prst="rect">
+            <a:avLst/>
+          </a:prstGeom>
+        </p:spPr>
+      </p:pic>
+    </p:spTree>
+    <p:extLst>
+      <p:ext uri="{BB962C8B-B14F-4D97-AF65-F5344CB8AC3E}">
+        <p14:creationId xmlns:p14="http://schemas.microsoft.com/office/powerpoint/2010/main" val="2905052628"/>
+      </p:ext>
+    </p:extLst>
+  </p:cSld>
+  <p:clrMapOvr>
+    <a:masterClrMapping/>
+  </p:clrMapOvr>
+</p:sld>
+</file>
+
+<file path=ppt/slides/slide6.xml><?xml version="1.0" encoding="utf-8"?>
+<p:sld xmlns:a="http://schemas.openxmlformats.org/drawingml/2006/main" xmlns:r="http://schemas.openxmlformats.org/officeDocument/2006/relationships" xmlns:p="http://schemas.openxmlformats.org/presentationml/2006/main">
+  <p:cSld>
+    <p:spTree>
+      <p:nvGrpSpPr>
+        <p:cNvPr id="1" name=""/>
+        <p:cNvGrpSpPr/>
+        <p:nvPr/>
+      </p:nvGrpSpPr>
+      <p:grpSpPr>
+        <a:xfrm>
+          <a:off x="0" y="0"/>
+          <a:ext cx="0" cy="0"/>
+          <a:chOff x="0" y="0"/>
+          <a:chExt cx="0" cy="0"/>
+        </a:xfrm>
+      </p:grpSpPr>
+      <p:pic>
+        <p:nvPicPr>
+          <p:cNvPr id="13" name="Image 12" descr="Une image contenant texte, capture d’écran, Police, logiciel&#10;&#10;Le contenu généré par l’IA peut être incorrect.">
+            <a:extLst>
+              <a:ext uri="{FF2B5EF4-FFF2-40B4-BE49-F238E27FC236}">
+                <a16:creationId xmlns:a16="http://schemas.microsoft.com/office/drawing/2014/main" id="{8E7AA2D2-3B92-AF3C-6D4E-2C64F045F9C7}"/>
+              </a:ext>
+            </a:extLst>
+          </p:cNvPr>
+          <p:cNvPicPr>
+            <a:picLocks noChangeAspect="1"/>
+          </p:cNvPicPr>
+          <p:nvPr/>
+        </p:nvPicPr>
+        <p:blipFill>
+          <a:blip r:embed="rId3"/>
+          <a:stretch>
+            <a:fillRect/>
+          </a:stretch>
+        </p:blipFill>
+        <p:spPr>
+          <a:xfrm>
+            <a:off x="6808762" y="1561374"/>
+            <a:ext cx="4769336" cy="1871223"/>
+          </a:xfrm>
+          <a:prstGeom prst="rect">
+            <a:avLst/>
+          </a:prstGeom>
+          <a:ln>
+            <a:noFill/>
+          </a:ln>
+          <a:effectLst>
+            <a:glow rad="63500">
+              <a:srgbClr val="C00000">
+                <a:alpha val="40000"/>
+              </a:srgbClr>
+            </a:glow>
+            <a:outerShdw blurRad="190500" algn="tl" rotWithShape="0">
+              <a:srgbClr val="000000">
+                <a:alpha val="70000"/>
+              </a:srgbClr>
+            </a:outerShdw>
+          </a:effectLst>
+        </p:spPr>
+      </p:pic>
+      <p:pic>
+        <p:nvPicPr>
+          <p:cNvPr id="15" name="Image 14" descr="Une image contenant texte, capture d’écran, Police, logo&#10;&#10;Le contenu généré par l’IA peut être incorrect.">
+            <a:extLst>
+              <a:ext uri="{FF2B5EF4-FFF2-40B4-BE49-F238E27FC236}">
+                <a16:creationId xmlns:a16="http://schemas.microsoft.com/office/drawing/2014/main" id="{48D18BB0-495D-3359-C7FC-183883DE4C0E}"/>
+              </a:ext>
+            </a:extLst>
+          </p:cNvPr>
+          <p:cNvPicPr>
+            <a:picLocks noChangeAspect="1"/>
+          </p:cNvPicPr>
+          <p:nvPr/>
+        </p:nvPicPr>
+        <p:blipFill>
+          <a:blip r:embed="rId4"/>
+          <a:stretch>
+            <a:fillRect/>
+          </a:stretch>
+        </p:blipFill>
+        <p:spPr>
+          <a:xfrm>
+            <a:off x="7349965" y="3475763"/>
+            <a:ext cx="4148778" cy="1809920"/>
+          </a:xfrm>
+          <a:prstGeom prst="rect">
+            <a:avLst/>
+          </a:prstGeom>
+          <a:ln>
+            <a:noFill/>
+          </a:ln>
+          <a:effectLst>
+            <a:glow rad="63500">
+              <a:srgbClr val="C00000">
+                <a:alpha val="40000"/>
+              </a:srgbClr>
+            </a:glow>
+            <a:outerShdw blurRad="190500" algn="tl" rotWithShape="0">
+              <a:srgbClr val="000000">
+                <a:alpha val="70000"/>
+              </a:srgbClr>
+            </a:outerShdw>
+          </a:effectLst>
+        </p:spPr>
+      </p:pic>
+      <p:pic>
+        <p:nvPicPr>
+          <p:cNvPr id="19" name="Image 18" descr="Une image contenant capture d’écran, carte, module&#10;&#10;Le contenu généré par l’IA peut être incorrect.">
+            <a:extLst>
+              <a:ext uri="{FF2B5EF4-FFF2-40B4-BE49-F238E27FC236}">
+                <a16:creationId xmlns:a16="http://schemas.microsoft.com/office/drawing/2014/main" id="{24A7732C-3E95-38F3-D104-9994B3148E84}"/>
+              </a:ext>
+            </a:extLst>
+          </p:cNvPr>
+          <p:cNvPicPr>
+            <a:picLocks noChangeAspect="1"/>
+          </p:cNvPicPr>
+          <p:nvPr/>
+        </p:nvPicPr>
+        <p:blipFill>
+          <a:blip r:embed="rId5"/>
+          <a:stretch>
+            <a:fillRect/>
+          </a:stretch>
+        </p:blipFill>
+        <p:spPr>
+          <a:xfrm>
+            <a:off x="465201" y="3966269"/>
+            <a:ext cx="5303004" cy="2101995"/>
+          </a:xfrm>
+          <a:prstGeom prst="rect">
+            <a:avLst/>
+          </a:prstGeom>
+          <a:ln>
+            <a:noFill/>
+          </a:ln>
+          <a:effectLst>
+            <a:glow rad="63500">
+              <a:srgbClr val="FFC000">
+                <a:alpha val="40000"/>
+              </a:srgbClr>
+            </a:glow>
+            <a:outerShdw blurRad="190500" algn="tl" rotWithShape="0">
+              <a:srgbClr val="000000">
+                <a:alpha val="70000"/>
+              </a:srgbClr>
+            </a:outerShdw>
+          </a:effectLst>
+        </p:spPr>
+      </p:pic>
+      <p:pic>
+        <p:nvPicPr>
+          <p:cNvPr id="21" name="Image 20" descr="Une image contenant texte, capture d’écran, affichage, logiciel&#10;&#10;Le contenu généré par l’IA peut être incorrect.">
+            <a:extLst>
+              <a:ext uri="{FF2B5EF4-FFF2-40B4-BE49-F238E27FC236}">
+                <a16:creationId xmlns:a16="http://schemas.microsoft.com/office/drawing/2014/main" id="{273AC57A-AD0E-8E2B-DA60-217D0E7E4D92}"/>
+              </a:ext>
+            </a:extLst>
+          </p:cNvPr>
+          <p:cNvPicPr>
+            <a:picLocks noChangeAspect="1"/>
+          </p:cNvPicPr>
+          <p:nvPr/>
+        </p:nvPicPr>
+        <p:blipFill>
+          <a:blip r:embed="rId6"/>
+          <a:stretch>
+            <a:fillRect/>
+          </a:stretch>
+        </p:blipFill>
+        <p:spPr>
+          <a:xfrm>
+            <a:off x="3515887" y="4987903"/>
+            <a:ext cx="1972315" cy="1758648"/>
+          </a:xfrm>
+          <a:prstGeom prst="rect">
+            <a:avLst/>
+          </a:prstGeom>
+          <a:ln>
+            <a:noFill/>
+          </a:ln>
+          <a:effectLst>
+            <a:glow rad="63500">
+              <a:schemeClr val="accent4">
+                <a:satMod val="175000"/>
+                <a:alpha val="40000"/>
+              </a:schemeClr>
+            </a:glow>
+            <a:outerShdw blurRad="190500" algn="tl" rotWithShape="0">
+              <a:srgbClr val="000000">
+                <a:alpha val="70000"/>
+              </a:srgbClr>
+            </a:outerShdw>
+          </a:effectLst>
+        </p:spPr>
+      </p:pic>
+      <p:pic>
+        <p:nvPicPr>
+          <p:cNvPr id="23" name="Image 22">
+            <a:extLst>
+              <a:ext uri="{FF2B5EF4-FFF2-40B4-BE49-F238E27FC236}">
+                <a16:creationId xmlns:a16="http://schemas.microsoft.com/office/drawing/2014/main" id="{69445FE3-B9BE-BAB7-880E-B46F27EFAAC7}"/>
+              </a:ext>
+            </a:extLst>
+          </p:cNvPr>
+          <p:cNvPicPr>
+            <a:picLocks noChangeAspect="1"/>
+          </p:cNvPicPr>
+          <p:nvPr/>
+        </p:nvPicPr>
+        <p:blipFill>
+          <a:blip r:embed="rId7"/>
+          <a:stretch>
+            <a:fillRect/>
+          </a:stretch>
+        </p:blipFill>
+        <p:spPr>
+          <a:xfrm>
+            <a:off x="199862" y="3709594"/>
+            <a:ext cx="4477138" cy="400085"/>
+          </a:xfrm>
+          <a:prstGeom prst="rect">
+            <a:avLst/>
+          </a:prstGeom>
+          <a:ln>
+            <a:noFill/>
+          </a:ln>
+          <a:effectLst>
+            <a:glow rad="63500">
+              <a:schemeClr val="accent4">
+                <a:satMod val="175000"/>
+                <a:alpha val="40000"/>
+              </a:schemeClr>
+            </a:glow>
+            <a:outerShdw blurRad="190500" algn="tl" rotWithShape="0">
+              <a:srgbClr val="000000">
+                <a:alpha val="70000"/>
+              </a:srgbClr>
+            </a:outerShdw>
+          </a:effectLst>
+        </p:spPr>
+      </p:pic>
+      <p:sp>
+        <p:nvSpPr>
+          <p:cNvPr id="31" name="Ellipse 30">
+            <a:extLst>
+              <a:ext uri="{FF2B5EF4-FFF2-40B4-BE49-F238E27FC236}">
+                <a16:creationId xmlns:a16="http://schemas.microsoft.com/office/drawing/2014/main" id="{98D46051-A22A-1122-427F-54418D16EFDE}"/>
+              </a:ext>
+            </a:extLst>
+          </p:cNvPr>
+          <p:cNvSpPr/>
+          <p:nvPr/>
+        </p:nvSpPr>
+        <p:spPr>
+          <a:xfrm rot="20704559" flipV="1">
+            <a:off x="1044526" y="5296585"/>
+            <a:ext cx="1072671" cy="230000"/>
+          </a:xfrm>
+          <a:prstGeom prst="ellipse">
+            <a:avLst/>
+          </a:prstGeom>
+          <a:noFill/>
+          <a:ln w="28575" cap="flat" cmpd="sng" algn="ctr">
+            <a:solidFill>
+              <a:schemeClr val="accent4"/>
+            </a:solidFill>
+            <a:prstDash val="solid"/>
+            <a:round/>
+            <a:headEnd type="none" w="med" len="med"/>
+            <a:tailEnd type="none" w="med" len="med"/>
+          </a:ln>
+        </p:spPr>
+        <p:style>
+          <a:lnRef idx="0">
+            <a:scrgbClr r="0" g="0" b="0"/>
+          </a:lnRef>
+          <a:fillRef idx="0">
+            <a:scrgbClr r="0" g="0" b="0"/>
+          </a:fillRef>
+          <a:effectRef idx="0">
+            <a:scrgbClr r="0" g="0" b="0"/>
+          </a:effectRef>
+          <a:fontRef idx="minor">
+            <a:schemeClr val="accent4"/>
+          </a:fontRef>
+        </p:style>
+        <p:txBody>
+          <a:bodyPr rtlCol="0" anchor="ctr"/>
+          <a:lstStyle/>
+          <a:p>
+            <a:pPr algn="ctr"/>
+            <a:endParaRPr lang="fr-FR" dirty="0"/>
+          </a:p>
+        </p:txBody>
+      </p:sp>
+      <p:cxnSp>
+        <p:nvCxnSpPr>
+          <p:cNvPr id="32" name="Connecteur droit avec flèche 31">
+            <a:extLst>
+              <a:ext uri="{FF2B5EF4-FFF2-40B4-BE49-F238E27FC236}">
+                <a16:creationId xmlns:a16="http://schemas.microsoft.com/office/drawing/2014/main" id="{23E91994-AB2F-D0CD-7ACC-39EA093F36C9}"/>
+              </a:ext>
+            </a:extLst>
+          </p:cNvPr>
+          <p:cNvCxnSpPr>
+            <a:cxnSpLocks/>
+            <a:stCxn id="31" idx="4"/>
+          </p:cNvCxnSpPr>
+          <p:nvPr/>
+        </p:nvCxnSpPr>
+        <p:spPr>
+          <a:xfrm flipV="1">
+            <a:off x="1551245" y="4109679"/>
+            <a:ext cx="860620" cy="1190785"/>
+          </a:xfrm>
+          <a:prstGeom prst="straightConnector1">
+            <a:avLst/>
+          </a:prstGeom>
+          <a:ln w="28575">
+            <a:solidFill>
+              <a:srgbClr val="0F9ED5"/>
+            </a:solidFill>
+            <a:tailEnd type="triangle"/>
+          </a:ln>
+        </p:spPr>
+        <p:style>
+          <a:lnRef idx="2">
+            <a:schemeClr val="accent1"/>
+          </a:lnRef>
+          <a:fillRef idx="0">
+            <a:schemeClr val="accent1"/>
+          </a:fillRef>
+          <a:effectRef idx="1">
+            <a:schemeClr val="accent1"/>
+          </a:effectRef>
+          <a:fontRef idx="minor">
+            <a:schemeClr val="tx1"/>
+          </a:fontRef>
+        </p:style>
+      </p:cxnSp>
+      <p:sp>
+        <p:nvSpPr>
+          <p:cNvPr id="37" name="Ellipse 36">
+            <a:extLst>
+              <a:ext uri="{FF2B5EF4-FFF2-40B4-BE49-F238E27FC236}">
+                <a16:creationId xmlns:a16="http://schemas.microsoft.com/office/drawing/2014/main" id="{3029F631-9504-C184-71BD-9782BA188B2D}"/>
+              </a:ext>
+            </a:extLst>
+          </p:cNvPr>
+          <p:cNvSpPr/>
+          <p:nvPr/>
+        </p:nvSpPr>
+        <p:spPr>
+          <a:xfrm rot="20704559" flipV="1">
+            <a:off x="1302427" y="5537264"/>
+            <a:ext cx="672380" cy="553683"/>
+          </a:xfrm>
+          <a:prstGeom prst="ellipse">
+            <a:avLst/>
+          </a:prstGeom>
+          <a:noFill/>
+          <a:ln w="28575" cap="flat" cmpd="sng" algn="ctr">
+            <a:solidFill>
+              <a:schemeClr val="accent4"/>
+            </a:solidFill>
+            <a:prstDash val="solid"/>
+            <a:round/>
+            <a:headEnd type="none" w="med" len="med"/>
+            <a:tailEnd type="none" w="med" len="med"/>
+          </a:ln>
+        </p:spPr>
+        <p:style>
+          <a:lnRef idx="0">
+            <a:scrgbClr r="0" g="0" b="0"/>
+          </a:lnRef>
+          <a:fillRef idx="0">
+            <a:scrgbClr r="0" g="0" b="0"/>
+          </a:fillRef>
+          <a:effectRef idx="0">
+            <a:scrgbClr r="0" g="0" b="0"/>
+          </a:effectRef>
+          <a:fontRef idx="minor">
+            <a:schemeClr val="accent4"/>
+          </a:fontRef>
+        </p:style>
+        <p:txBody>
+          <a:bodyPr rtlCol="0" anchor="ctr"/>
+          <a:lstStyle/>
+          <a:p>
+            <a:pPr algn="ctr"/>
+            <a:endParaRPr lang="fr-FR" dirty="0"/>
+          </a:p>
+        </p:txBody>
+      </p:sp>
+      <p:cxnSp>
+        <p:nvCxnSpPr>
+          <p:cNvPr id="38" name="Connecteur droit avec flèche 37">
+            <a:extLst>
+              <a:ext uri="{FF2B5EF4-FFF2-40B4-BE49-F238E27FC236}">
+                <a16:creationId xmlns:a16="http://schemas.microsoft.com/office/drawing/2014/main" id="{B10008DF-EE82-D72B-782A-AF3A7B5AC75D}"/>
+              </a:ext>
+            </a:extLst>
+          </p:cNvPr>
+          <p:cNvCxnSpPr>
+            <a:cxnSpLocks/>
+            <a:stCxn id="37" idx="7"/>
+            <a:endCxn id="21" idx="1"/>
+          </p:cNvCxnSpPr>
+          <p:nvPr/>
+        </p:nvCxnSpPr>
+        <p:spPr>
+          <a:xfrm flipV="1">
+            <a:off x="1918735" y="5867227"/>
+            <a:ext cx="1597152" cy="74809"/>
+          </a:xfrm>
+          <a:prstGeom prst="straightConnector1">
+            <a:avLst/>
+          </a:prstGeom>
+          <a:ln w="28575">
+            <a:solidFill>
+              <a:srgbClr val="0F9ED5"/>
+            </a:solidFill>
+            <a:tailEnd type="triangle"/>
+          </a:ln>
+        </p:spPr>
+        <p:style>
+          <a:lnRef idx="2">
+            <a:schemeClr val="accent1"/>
+          </a:lnRef>
+          <a:fillRef idx="0">
+            <a:schemeClr val="accent1"/>
+          </a:fillRef>
+          <a:effectRef idx="1">
+            <a:schemeClr val="accent1"/>
+          </a:effectRef>
+          <a:fontRef idx="minor">
+            <a:schemeClr val="tx1"/>
+          </a:fontRef>
+        </p:style>
+      </p:cxnSp>
+      <p:grpSp>
+        <p:nvGrpSpPr>
+          <p:cNvPr id="44" name="Groupe 43">
+            <a:extLst>
+              <a:ext uri="{FF2B5EF4-FFF2-40B4-BE49-F238E27FC236}">
+                <a16:creationId xmlns:a16="http://schemas.microsoft.com/office/drawing/2014/main" id="{DC16C9F7-E5EC-2DB4-4CA5-D7E7D98B6ABF}"/>
+              </a:ext>
+            </a:extLst>
+          </p:cNvPr>
+          <p:cNvGrpSpPr/>
+          <p:nvPr/>
+        </p:nvGrpSpPr>
+        <p:grpSpPr>
+          <a:xfrm>
+            <a:off x="182854" y="134421"/>
+            <a:ext cx="6260620" cy="3043042"/>
+            <a:chOff x="182854" y="231182"/>
+            <a:chExt cx="6260620" cy="3043042"/>
+          </a:xfrm>
+        </p:grpSpPr>
+        <p:grpSp>
+          <p:nvGrpSpPr>
+            <p:cNvPr id="24" name="Groupe 23">
+              <a:extLst>
+                <a:ext uri="{FF2B5EF4-FFF2-40B4-BE49-F238E27FC236}">
+                  <a16:creationId xmlns:a16="http://schemas.microsoft.com/office/drawing/2014/main" id="{E9E8C4D4-6C3C-1A1B-0855-F824E472007B}"/>
+                </a:ext>
+              </a:extLst>
+            </p:cNvPr>
+            <p:cNvGrpSpPr/>
+            <p:nvPr/>
+          </p:nvGrpSpPr>
+          <p:grpSpPr>
+            <a:xfrm>
+              <a:off x="182854" y="231182"/>
+              <a:ext cx="6250944" cy="3043042"/>
+              <a:chOff x="182854" y="231182"/>
+              <a:chExt cx="6250944" cy="3043042"/>
+            </a:xfrm>
+          </p:grpSpPr>
+          <p:pic>
+            <p:nvPicPr>
+              <p:cNvPr id="7" name="Image 6" descr="Une image contenant texte, capture d’écran, logiciel, Logiciel multimédia&#10;&#10;Le contenu généré par l’IA peut être incorrect.">
+                <a:extLst>
+                  <a:ext uri="{FF2B5EF4-FFF2-40B4-BE49-F238E27FC236}">
+                    <a16:creationId xmlns:a16="http://schemas.microsoft.com/office/drawing/2014/main" id="{8BF13A8C-613B-D07B-C120-11C136641A3E}"/>
+                  </a:ext>
+                </a:extLst>
+              </p:cNvPr>
+              <p:cNvPicPr>
+                <a:picLocks noChangeAspect="1"/>
+              </p:cNvPicPr>
+              <p:nvPr/>
+            </p:nvPicPr>
+            <p:blipFill>
+              <a:blip r:embed="rId8"/>
+              <a:stretch>
+                <a:fillRect/>
+              </a:stretch>
+            </p:blipFill>
+            <p:spPr>
+              <a:xfrm>
+                <a:off x="182854" y="231182"/>
+                <a:ext cx="6250944" cy="2698402"/>
+              </a:xfrm>
+              <a:prstGeom prst="rect">
+                <a:avLst/>
+              </a:prstGeom>
+              <a:ln>
+                <a:noFill/>
+              </a:ln>
+              <a:effectLst>
+                <a:glow rad="63500">
+                  <a:srgbClr val="FFC000">
+                    <a:alpha val="40000"/>
+                  </a:srgbClr>
+                </a:glow>
+                <a:outerShdw blurRad="190500" algn="tl" rotWithShape="0">
+                  <a:srgbClr val="000000">
+                    <a:alpha val="70000"/>
+                  </a:srgbClr>
+                </a:outerShdw>
+              </a:effectLst>
+            </p:spPr>
+          </p:pic>
+          <p:pic>
+            <p:nvPicPr>
+              <p:cNvPr id="9" name="Image 8" descr="Une image contenant texte, capture d’écran, Police, conception&#10;&#10;Le contenu généré par l’IA peut être incorrect.">
+                <a:extLst>
+                  <a:ext uri="{FF2B5EF4-FFF2-40B4-BE49-F238E27FC236}">
+                    <a16:creationId xmlns:a16="http://schemas.microsoft.com/office/drawing/2014/main" id="{735673BB-83EC-51B2-922F-45179D7E9CDA}"/>
+                  </a:ext>
+                </a:extLst>
+              </p:cNvPr>
+              <p:cNvPicPr>
+                <a:picLocks noChangeAspect="1"/>
+              </p:cNvPicPr>
+              <p:nvPr/>
+            </p:nvPicPr>
+            <p:blipFill>
+              <a:blip r:embed="rId9"/>
+              <a:stretch>
+                <a:fillRect/>
+              </a:stretch>
+            </p:blipFill>
+            <p:spPr>
+              <a:xfrm>
+                <a:off x="2874758" y="1882988"/>
+                <a:ext cx="1785234" cy="1391236"/>
+              </a:xfrm>
+              <a:prstGeom prst="rect">
+                <a:avLst/>
+              </a:prstGeom>
+              <a:ln>
+                <a:noFill/>
+              </a:ln>
+              <a:effectLst>
+                <a:glow rad="63500">
+                  <a:schemeClr val="accent4">
+                    <a:satMod val="175000"/>
+                    <a:alpha val="40000"/>
+                  </a:schemeClr>
+                </a:glow>
+                <a:outerShdw blurRad="190500" algn="tl" rotWithShape="0">
+                  <a:srgbClr val="000000">
+                    <a:alpha val="70000"/>
+                  </a:srgbClr>
+                </a:outerShdw>
+              </a:effectLst>
+            </p:spPr>
+          </p:pic>
+        </p:grpSp>
+        <p:pic>
+          <p:nvPicPr>
+            <p:cNvPr id="43" name="Image 42" descr="Une image contenant texte, capture d’écran, Police, nombre&#10;&#10;Le contenu généré par l’IA peut être incorrect.">
+              <a:extLst>
+                <a:ext uri="{FF2B5EF4-FFF2-40B4-BE49-F238E27FC236}">
+                  <a16:creationId xmlns:a16="http://schemas.microsoft.com/office/drawing/2014/main" id="{299FE722-AF50-B987-2322-211B62CB2FEA}"/>
+                </a:ext>
+              </a:extLst>
+            </p:cNvPr>
+            <p:cNvPicPr>
+              <a:picLocks noChangeAspect="1"/>
+            </p:cNvPicPr>
+            <p:nvPr/>
+          </p:nvPicPr>
+          <p:blipFill>
+            <a:blip r:embed="rId10"/>
+            <a:stretch>
+              <a:fillRect/>
+            </a:stretch>
+          </p:blipFill>
+          <p:spPr>
+            <a:xfrm>
+              <a:off x="4710564" y="1161399"/>
+              <a:ext cx="1732910" cy="2024860"/>
+            </a:xfrm>
+            <a:prstGeom prst="rect">
+              <a:avLst/>
+            </a:prstGeom>
+            <a:ln>
+              <a:noFill/>
+            </a:ln>
+            <a:effectLst>
+              <a:glow rad="63500">
+                <a:schemeClr val="accent4">
+                  <a:satMod val="175000"/>
+                  <a:alpha val="40000"/>
+                </a:schemeClr>
+              </a:glow>
+              <a:outerShdw blurRad="190500" algn="tl" rotWithShape="0">
+                <a:srgbClr val="000000">
+                  <a:alpha val="70000"/>
+                </a:srgbClr>
+              </a:outerShdw>
+            </a:effectLst>
+          </p:spPr>
+        </p:pic>
+      </p:grpSp>
+      <p:grpSp>
+        <p:nvGrpSpPr>
+          <p:cNvPr id="30" name="Groupe 29">
+            <a:extLst>
+              <a:ext uri="{FF2B5EF4-FFF2-40B4-BE49-F238E27FC236}">
+                <a16:creationId xmlns:a16="http://schemas.microsoft.com/office/drawing/2014/main" id="{4CC90A6A-5E0A-A7F8-1637-B569DCF7B5F5}"/>
+              </a:ext>
+            </a:extLst>
+          </p:cNvPr>
+          <p:cNvGrpSpPr/>
+          <p:nvPr/>
+        </p:nvGrpSpPr>
+        <p:grpSpPr>
+          <a:xfrm>
+            <a:off x="140304" y="161334"/>
+            <a:ext cx="1991522" cy="2105246"/>
+            <a:chOff x="140304" y="258095"/>
+            <a:chExt cx="1991522" cy="2105246"/>
+          </a:xfrm>
+        </p:grpSpPr>
+        <p:grpSp>
+          <p:nvGrpSpPr>
+            <p:cNvPr id="28" name="Groupe 27">
+              <a:extLst>
+                <a:ext uri="{FF2B5EF4-FFF2-40B4-BE49-F238E27FC236}">
+                  <a16:creationId xmlns:a16="http://schemas.microsoft.com/office/drawing/2014/main" id="{8C4BCF51-EBC7-7690-BF81-09664954F19E}"/>
+                </a:ext>
+              </a:extLst>
+            </p:cNvPr>
+            <p:cNvGrpSpPr/>
+            <p:nvPr/>
+          </p:nvGrpSpPr>
+          <p:grpSpPr>
+            <a:xfrm>
+              <a:off x="140304" y="258095"/>
+              <a:ext cx="1475619" cy="1565867"/>
+              <a:chOff x="140304" y="258095"/>
+              <a:chExt cx="1475619" cy="1565867"/>
+            </a:xfrm>
+          </p:grpSpPr>
+          <p:sp>
+            <p:nvSpPr>
+              <p:cNvPr id="25" name="Ellipse 24">
+                <a:extLst>
+                  <a:ext uri="{FF2B5EF4-FFF2-40B4-BE49-F238E27FC236}">
+                    <a16:creationId xmlns:a16="http://schemas.microsoft.com/office/drawing/2014/main" id="{DC45352D-22BF-37C2-07CA-958A66DF24CC}"/>
+                  </a:ext>
+                </a:extLst>
+              </p:cNvPr>
+              <p:cNvSpPr/>
+              <p:nvPr/>
+            </p:nvSpPr>
+            <p:spPr>
+              <a:xfrm>
+                <a:off x="140304" y="258095"/>
+                <a:ext cx="1475619" cy="864344"/>
+              </a:xfrm>
+              <a:prstGeom prst="ellipse">
+                <a:avLst/>
+              </a:prstGeom>
+              <a:noFill/>
+              <a:ln w="28575" cap="flat" cmpd="sng" algn="ctr">
+                <a:solidFill>
+                  <a:schemeClr val="accent4"/>
+                </a:solidFill>
+                <a:prstDash val="solid"/>
+                <a:round/>
+                <a:headEnd type="none" w="med" len="med"/>
+                <a:tailEnd type="none" w="med" len="med"/>
+              </a:ln>
+            </p:spPr>
+            <p:style>
+              <a:lnRef idx="0">
+                <a:scrgbClr r="0" g="0" b="0"/>
+              </a:lnRef>
+              <a:fillRef idx="0">
+                <a:scrgbClr r="0" g="0" b="0"/>
+              </a:fillRef>
+              <a:effectRef idx="0">
+                <a:scrgbClr r="0" g="0" b="0"/>
+              </a:effectRef>
+              <a:fontRef idx="minor">
+                <a:schemeClr val="accent4"/>
+              </a:fontRef>
+            </p:style>
+            <p:txBody>
+              <a:bodyPr rtlCol="0" anchor="ctr"/>
+              <a:lstStyle/>
+              <a:p>
+                <a:pPr algn="ctr"/>
+                <a:endParaRPr lang="fr-FR" dirty="0"/>
+              </a:p>
+            </p:txBody>
+          </p:sp>
+          <p:cxnSp>
+            <p:nvCxnSpPr>
+              <p:cNvPr id="27" name="Connecteur droit avec flèche 26">
+                <a:extLst>
+                  <a:ext uri="{FF2B5EF4-FFF2-40B4-BE49-F238E27FC236}">
+                    <a16:creationId xmlns:a16="http://schemas.microsoft.com/office/drawing/2014/main" id="{0B2E76E8-982B-EA58-FB41-9A14A209AE1C}"/>
+                  </a:ext>
+                </a:extLst>
+              </p:cNvPr>
+              <p:cNvCxnSpPr/>
+              <p:nvPr/>
+            </p:nvCxnSpPr>
+            <p:spPr>
+              <a:xfrm>
+                <a:off x="878113" y="1122439"/>
+                <a:ext cx="0" cy="701523"/>
+              </a:xfrm>
+              <a:prstGeom prst="straightConnector1">
+                <a:avLst/>
+              </a:prstGeom>
+              <a:ln w="28575">
+                <a:solidFill>
+                  <a:srgbClr val="0F9ED5"/>
+                </a:solidFill>
+                <a:tailEnd type="triangle"/>
+              </a:ln>
+            </p:spPr>
+            <p:style>
+              <a:lnRef idx="2">
+                <a:schemeClr val="accent1"/>
+              </a:lnRef>
+              <a:fillRef idx="0">
+                <a:schemeClr val="accent1"/>
+              </a:fillRef>
+              <a:effectRef idx="1">
+                <a:schemeClr val="accent1"/>
+              </a:effectRef>
+              <a:fontRef idx="minor">
+                <a:schemeClr val="tx1"/>
+              </a:fontRef>
+            </p:style>
+          </p:cxnSp>
+        </p:grpSp>
+        <p:sp>
+          <p:nvSpPr>
+            <p:cNvPr id="29" name="ZoneTexte 28">
+              <a:extLst>
+                <a:ext uri="{FF2B5EF4-FFF2-40B4-BE49-F238E27FC236}">
+                  <a16:creationId xmlns:a16="http://schemas.microsoft.com/office/drawing/2014/main" id="{C1FA3043-A4E7-3E14-C31C-29EE057C1175}"/>
+                </a:ext>
+              </a:extLst>
+            </p:cNvPr>
+            <p:cNvSpPr txBox="1"/>
+            <p:nvPr/>
+          </p:nvSpPr>
+          <p:spPr>
+            <a:xfrm>
+              <a:off x="346593" y="1840121"/>
+              <a:ext cx="1785233" cy="523220"/>
+            </a:xfrm>
+            <a:prstGeom prst="rect">
+              <a:avLst/>
+            </a:prstGeom>
+            <a:noFill/>
+          </p:spPr>
+          <p:txBody>
+            <a:bodyPr wrap="square" rtlCol="0">
+              <a:spAutoFit/>
+            </a:bodyPr>
+            <a:lstStyle/>
+            <a:p>
+              <a:r>
+                <a:rPr lang="en-US" sz="1400" b="1" noProof="0" dirty="0">
+                  <a:solidFill>
+                    <a:srgbClr val="0F9ED5"/>
+                  </a:solidFill>
+                </a:rPr>
+                <a:t>Agent commanding the type of input</a:t>
+              </a:r>
+            </a:p>
+          </p:txBody>
+        </p:sp>
+      </p:grpSp>
+      <p:sp>
+        <p:nvSpPr>
+          <p:cNvPr id="47" name="Ellipse 46">
+            <a:extLst>
+              <a:ext uri="{FF2B5EF4-FFF2-40B4-BE49-F238E27FC236}">
+                <a16:creationId xmlns:a16="http://schemas.microsoft.com/office/drawing/2014/main" id="{C2E49673-0BE2-9541-536C-82ECA8A1FCA1}"/>
+              </a:ext>
+            </a:extLst>
+          </p:cNvPr>
+          <p:cNvSpPr/>
+          <p:nvPr/>
+        </p:nvSpPr>
+        <p:spPr>
+          <a:xfrm flipV="1">
+            <a:off x="1973944" y="420913"/>
+            <a:ext cx="2530324" cy="878759"/>
+          </a:xfrm>
+          <a:prstGeom prst="ellipse">
+            <a:avLst/>
+          </a:prstGeom>
+          <a:noFill/>
+          <a:ln w="28575" cap="flat" cmpd="sng" algn="ctr">
+            <a:solidFill>
+              <a:schemeClr val="accent4"/>
+            </a:solidFill>
+            <a:prstDash val="solid"/>
+            <a:round/>
+            <a:headEnd type="none" w="med" len="med"/>
+            <a:tailEnd type="none" w="med" len="med"/>
+          </a:ln>
+        </p:spPr>
+        <p:style>
+          <a:lnRef idx="0">
+            <a:scrgbClr r="0" g="0" b="0"/>
+          </a:lnRef>
+          <a:fillRef idx="0">
+            <a:scrgbClr r="0" g="0" b="0"/>
+          </a:fillRef>
+          <a:effectRef idx="0">
+            <a:scrgbClr r="0" g="0" b="0"/>
+          </a:effectRef>
+          <a:fontRef idx="minor">
+            <a:schemeClr val="accent4"/>
+          </a:fontRef>
+        </p:style>
+        <p:txBody>
+          <a:bodyPr rtlCol="0" anchor="ctr"/>
+          <a:lstStyle/>
+          <a:p>
+            <a:pPr algn="ctr"/>
+            <a:endParaRPr lang="fr-FR" dirty="0"/>
+          </a:p>
+        </p:txBody>
+      </p:sp>
+      <p:sp>
+        <p:nvSpPr>
+          <p:cNvPr id="62" name="Ellipse 61">
+            <a:extLst>
+              <a:ext uri="{FF2B5EF4-FFF2-40B4-BE49-F238E27FC236}">
+                <a16:creationId xmlns:a16="http://schemas.microsoft.com/office/drawing/2014/main" id="{CAD77020-01B8-5D38-F694-2742896F1B4B}"/>
+              </a:ext>
+            </a:extLst>
+          </p:cNvPr>
+          <p:cNvSpPr/>
+          <p:nvPr/>
+        </p:nvSpPr>
+        <p:spPr>
+          <a:xfrm flipV="1">
+            <a:off x="1805593" y="299958"/>
+            <a:ext cx="2790597" cy="1125897"/>
+          </a:xfrm>
+          <a:prstGeom prst="ellipse">
+            <a:avLst/>
+          </a:prstGeom>
+          <a:noFill/>
+          <a:ln w="28575" cap="flat" cmpd="sng" algn="ctr">
+            <a:solidFill>
+              <a:srgbClr val="FFC000"/>
+            </a:solidFill>
+            <a:prstDash val="solid"/>
+            <a:round/>
+            <a:headEnd type="none" w="med" len="med"/>
+            <a:tailEnd type="none" w="med" len="med"/>
+          </a:ln>
+        </p:spPr>
+        <p:style>
+          <a:lnRef idx="0">
+            <a:scrgbClr r="0" g="0" b="0"/>
+          </a:lnRef>
+          <a:fillRef idx="0">
+            <a:scrgbClr r="0" g="0" b="0"/>
+          </a:fillRef>
+          <a:effectRef idx="0">
+            <a:scrgbClr r="0" g="0" b="0"/>
+          </a:effectRef>
+          <a:fontRef idx="minor">
+            <a:schemeClr val="accent4"/>
+          </a:fontRef>
+        </p:style>
+        <p:txBody>
+          <a:bodyPr rtlCol="0" anchor="ctr"/>
+          <a:lstStyle/>
+          <a:p>
+            <a:pPr algn="ctr"/>
+            <a:endParaRPr lang="fr-FR" dirty="0"/>
+          </a:p>
+        </p:txBody>
+      </p:sp>
+      <p:cxnSp>
+        <p:nvCxnSpPr>
+          <p:cNvPr id="63" name="Connecteur droit avec flèche 62">
+            <a:extLst>
+              <a:ext uri="{FF2B5EF4-FFF2-40B4-BE49-F238E27FC236}">
+                <a16:creationId xmlns:a16="http://schemas.microsoft.com/office/drawing/2014/main" id="{09931F23-BE54-89E0-6910-084B2160E0D6}"/>
+              </a:ext>
+            </a:extLst>
+          </p:cNvPr>
+          <p:cNvCxnSpPr>
+            <a:cxnSpLocks/>
+            <a:stCxn id="120" idx="6"/>
+            <a:endCxn id="108" idx="1"/>
+          </p:cNvCxnSpPr>
+          <p:nvPr/>
+        </p:nvCxnSpPr>
+        <p:spPr>
+          <a:xfrm flipV="1">
+            <a:off x="4753113" y="798209"/>
+            <a:ext cx="2617840" cy="57895"/>
+          </a:xfrm>
+          <a:prstGeom prst="straightConnector1">
+            <a:avLst/>
+          </a:prstGeom>
+          <a:ln w="28575">
+            <a:solidFill>
+              <a:srgbClr val="C00000"/>
+            </a:solidFill>
+            <a:tailEnd type="triangle"/>
+          </a:ln>
+        </p:spPr>
+        <p:style>
+          <a:lnRef idx="2">
+            <a:schemeClr val="accent1"/>
+          </a:lnRef>
+          <a:fillRef idx="0">
+            <a:schemeClr val="accent1"/>
+          </a:fillRef>
+          <a:effectRef idx="1">
+            <a:schemeClr val="accent1"/>
+          </a:effectRef>
+          <a:fontRef idx="minor">
+            <a:schemeClr val="tx1"/>
+          </a:fontRef>
+        </p:style>
+      </p:cxnSp>
+      <p:sp>
+        <p:nvSpPr>
+          <p:cNvPr id="68" name="Ellipse 67">
+            <a:extLst>
+              <a:ext uri="{FF2B5EF4-FFF2-40B4-BE49-F238E27FC236}">
+                <a16:creationId xmlns:a16="http://schemas.microsoft.com/office/drawing/2014/main" id="{1016071D-9F53-7911-CA28-7164A9E79B00}"/>
+              </a:ext>
+            </a:extLst>
+          </p:cNvPr>
+          <p:cNvSpPr/>
+          <p:nvPr/>
+        </p:nvSpPr>
+        <p:spPr>
+          <a:xfrm flipV="1">
+            <a:off x="8086580" y="2633518"/>
+            <a:ext cx="1924072" cy="341437"/>
+          </a:xfrm>
+          <a:prstGeom prst="ellipse">
+            <a:avLst/>
+          </a:prstGeom>
+          <a:noFill/>
+          <a:ln w="28575" cap="flat" cmpd="sng" algn="ctr">
+            <a:solidFill>
+              <a:srgbClr val="FFC000"/>
+            </a:solidFill>
+            <a:prstDash val="solid"/>
+            <a:round/>
+            <a:headEnd type="none" w="med" len="med"/>
+            <a:tailEnd type="none" w="med" len="med"/>
+          </a:ln>
+        </p:spPr>
+        <p:style>
+          <a:lnRef idx="0">
+            <a:scrgbClr r="0" g="0" b="0"/>
+          </a:lnRef>
+          <a:fillRef idx="0">
+            <a:scrgbClr r="0" g="0" b="0"/>
+          </a:fillRef>
+          <a:effectRef idx="0">
+            <a:scrgbClr r="0" g="0" b="0"/>
+          </a:effectRef>
+          <a:fontRef idx="minor">
+            <a:schemeClr val="accent4"/>
+          </a:fontRef>
+        </p:style>
+        <p:txBody>
+          <a:bodyPr rtlCol="0" anchor="ctr"/>
+          <a:lstStyle/>
+          <a:p>
+            <a:pPr algn="ctr"/>
+            <a:endParaRPr lang="fr-FR" dirty="0"/>
+          </a:p>
+        </p:txBody>
+      </p:sp>
+      <p:cxnSp>
+        <p:nvCxnSpPr>
+          <p:cNvPr id="69" name="Connecteur droit avec flèche 68">
+            <a:extLst>
+              <a:ext uri="{FF2B5EF4-FFF2-40B4-BE49-F238E27FC236}">
+                <a16:creationId xmlns:a16="http://schemas.microsoft.com/office/drawing/2014/main" id="{1AAA7B50-38C3-9C99-9DD4-A21B81AE2A00}"/>
+              </a:ext>
+            </a:extLst>
+          </p:cNvPr>
+          <p:cNvCxnSpPr>
+            <a:cxnSpLocks/>
+            <a:stCxn id="68" idx="2"/>
+            <a:endCxn id="19" idx="3"/>
+          </p:cNvCxnSpPr>
+          <p:nvPr/>
+        </p:nvCxnSpPr>
+        <p:spPr>
+          <a:xfrm flipH="1">
+            <a:off x="5768205" y="2804236"/>
+            <a:ext cx="2318375" cy="2213031"/>
+          </a:xfrm>
+          <a:prstGeom prst="straightConnector1">
+            <a:avLst/>
+          </a:prstGeom>
+          <a:ln w="28575">
+            <a:solidFill>
+              <a:srgbClr val="FFC000"/>
+            </a:solidFill>
+            <a:tailEnd type="triangle"/>
+          </a:ln>
+        </p:spPr>
+        <p:style>
+          <a:lnRef idx="2">
+            <a:schemeClr val="accent1"/>
+          </a:lnRef>
+          <a:fillRef idx="0">
+            <a:schemeClr val="accent1"/>
+          </a:fillRef>
+          <a:effectRef idx="1">
+            <a:schemeClr val="accent1"/>
+          </a:effectRef>
+          <a:fontRef idx="minor">
+            <a:schemeClr val="tx1"/>
+          </a:fontRef>
+        </p:style>
+      </p:cxnSp>
+      <p:sp>
+        <p:nvSpPr>
+          <p:cNvPr id="75" name="Ellipse 74">
+            <a:extLst>
+              <a:ext uri="{FF2B5EF4-FFF2-40B4-BE49-F238E27FC236}">
+                <a16:creationId xmlns:a16="http://schemas.microsoft.com/office/drawing/2014/main" id="{C5DF8A31-9624-DCA2-51C3-4FAE6F5D8C9A}"/>
+              </a:ext>
+            </a:extLst>
+          </p:cNvPr>
+          <p:cNvSpPr/>
+          <p:nvPr/>
+        </p:nvSpPr>
+        <p:spPr>
+          <a:xfrm flipV="1">
+            <a:off x="8162841" y="2904144"/>
+            <a:ext cx="1924072" cy="217717"/>
+          </a:xfrm>
+          <a:prstGeom prst="ellipse">
+            <a:avLst/>
+          </a:prstGeom>
+          <a:noFill/>
+          <a:ln w="28575" cap="flat" cmpd="sng" algn="ctr">
+            <a:solidFill>
+              <a:srgbClr val="FFC000"/>
+            </a:solidFill>
+            <a:prstDash val="solid"/>
+            <a:round/>
+            <a:headEnd type="none" w="med" len="med"/>
+            <a:tailEnd type="none" w="med" len="med"/>
+          </a:ln>
+        </p:spPr>
+        <p:style>
+          <a:lnRef idx="0">
+            <a:scrgbClr r="0" g="0" b="0"/>
+          </a:lnRef>
+          <a:fillRef idx="0">
+            <a:scrgbClr r="0" g="0" b="0"/>
+          </a:fillRef>
+          <a:effectRef idx="0">
+            <a:scrgbClr r="0" g="0" b="0"/>
+          </a:effectRef>
+          <a:fontRef idx="minor">
+            <a:schemeClr val="accent4"/>
+          </a:fontRef>
+        </p:style>
+        <p:txBody>
+          <a:bodyPr rtlCol="0" anchor="ctr"/>
+          <a:lstStyle/>
+          <a:p>
+            <a:pPr algn="ctr"/>
+            <a:endParaRPr lang="fr-FR" dirty="0"/>
+          </a:p>
+        </p:txBody>
+      </p:sp>
+      <p:sp>
+        <p:nvSpPr>
+          <p:cNvPr id="82" name="ZoneTexte 81">
+            <a:extLst>
+              <a:ext uri="{FF2B5EF4-FFF2-40B4-BE49-F238E27FC236}">
+                <a16:creationId xmlns:a16="http://schemas.microsoft.com/office/drawing/2014/main" id="{0010D6A7-E98F-24C1-A31E-5EBC361AFF27}"/>
+              </a:ext>
+            </a:extLst>
+          </p:cNvPr>
+          <p:cNvSpPr txBox="1"/>
+          <p:nvPr/>
+        </p:nvSpPr>
+        <p:spPr>
+          <a:xfrm>
+            <a:off x="7805356" y="2316393"/>
+            <a:ext cx="4342857" cy="307777"/>
+          </a:xfrm>
+          <a:prstGeom prst="rect">
+            <a:avLst/>
+          </a:prstGeom>
+          <a:noFill/>
+        </p:spPr>
+        <p:txBody>
+          <a:bodyPr wrap="square" rtlCol="0">
+            <a:spAutoFit/>
+          </a:bodyPr>
+          <a:lstStyle/>
+          <a:p>
+            <a:r>
+              <a:rPr lang="en-US" sz="1400" b="1" noProof="0" dirty="0">
+                <a:solidFill>
+                  <a:srgbClr val="FFC000"/>
+                </a:solidFill>
+              </a:rPr>
+              <a:t>PlantSimulatio</a:t>
+            </a:r>
+            <a:r>
+              <a:rPr lang="en-US" sz="1400" b="1" dirty="0">
+                <a:solidFill>
+                  <a:srgbClr val="FFC000"/>
+                </a:solidFill>
+              </a:rPr>
+              <a:t>n M&amp;S Client (SUBSCRIBER)</a:t>
+            </a:r>
+            <a:endParaRPr lang="en-US" sz="1400" b="1" noProof="0" dirty="0">
+              <a:solidFill>
+                <a:srgbClr val="FFC000"/>
+              </a:solidFill>
+            </a:endParaRPr>
+          </a:p>
+        </p:txBody>
+      </p:sp>
+      <p:sp>
+        <p:nvSpPr>
+          <p:cNvPr id="83" name="ZoneTexte 82">
+            <a:extLst>
+              <a:ext uri="{FF2B5EF4-FFF2-40B4-BE49-F238E27FC236}">
+                <a16:creationId xmlns:a16="http://schemas.microsoft.com/office/drawing/2014/main" id="{F424D302-80E5-82C6-3C01-E8BF22F90192}"/>
+              </a:ext>
+            </a:extLst>
+          </p:cNvPr>
+          <p:cNvSpPr txBox="1"/>
+          <p:nvPr/>
+        </p:nvSpPr>
+        <p:spPr>
+          <a:xfrm>
+            <a:off x="7737455" y="3065357"/>
+            <a:ext cx="4546394" cy="307777"/>
+          </a:xfrm>
+          <a:prstGeom prst="rect">
+            <a:avLst/>
+          </a:prstGeom>
+          <a:noFill/>
+        </p:spPr>
+        <p:txBody>
+          <a:bodyPr wrap="square" rtlCol="0">
+            <a:spAutoFit/>
+          </a:bodyPr>
+          <a:lstStyle/>
+          <a:p>
+            <a:r>
+              <a:rPr lang="en-US" sz="1400" b="1" noProof="0" dirty="0">
+                <a:solidFill>
+                  <a:srgbClr val="FFC000"/>
+                </a:solidFill>
+              </a:rPr>
+              <a:t>Ingescape Agent </a:t>
+            </a:r>
+            <a:r>
+              <a:rPr lang="en-US" sz="1400" b="1" dirty="0">
+                <a:solidFill>
+                  <a:srgbClr val="FFC000"/>
+                </a:solidFill>
+              </a:rPr>
+              <a:t>Client (SUBSCRIBER &amp; PUBLISHER)</a:t>
+            </a:r>
+            <a:endParaRPr lang="en-US" sz="1400" b="1" noProof="0" dirty="0">
+              <a:solidFill>
+                <a:srgbClr val="FFC000"/>
+              </a:solidFill>
+            </a:endParaRPr>
+          </a:p>
+        </p:txBody>
+      </p:sp>
+      <p:grpSp>
+        <p:nvGrpSpPr>
+          <p:cNvPr id="92" name="Groupe 91">
+            <a:extLst>
+              <a:ext uri="{FF2B5EF4-FFF2-40B4-BE49-F238E27FC236}">
+                <a16:creationId xmlns:a16="http://schemas.microsoft.com/office/drawing/2014/main" id="{540A31F2-8053-DC9B-095A-2EF448AC5CAC}"/>
+              </a:ext>
+            </a:extLst>
+          </p:cNvPr>
+          <p:cNvGrpSpPr/>
+          <p:nvPr/>
+        </p:nvGrpSpPr>
+        <p:grpSpPr>
+          <a:xfrm>
+            <a:off x="8929913" y="4546428"/>
+            <a:ext cx="2796886" cy="1694035"/>
+            <a:chOff x="105587" y="258095"/>
+            <a:chExt cx="1988731" cy="1905898"/>
+          </a:xfrm>
+        </p:grpSpPr>
+        <p:grpSp>
+          <p:nvGrpSpPr>
+            <p:cNvPr id="93" name="Groupe 92">
+              <a:extLst>
+                <a:ext uri="{FF2B5EF4-FFF2-40B4-BE49-F238E27FC236}">
+                  <a16:creationId xmlns:a16="http://schemas.microsoft.com/office/drawing/2014/main" id="{C9F4C9AC-9E43-C0D1-3FBF-CB0B5ABC4CDB}"/>
+                </a:ext>
+              </a:extLst>
+            </p:cNvPr>
+            <p:cNvGrpSpPr/>
+            <p:nvPr/>
+          </p:nvGrpSpPr>
+          <p:grpSpPr>
+            <a:xfrm>
+              <a:off x="140304" y="258095"/>
+              <a:ext cx="1475619" cy="1317242"/>
+              <a:chOff x="140304" y="258095"/>
+              <a:chExt cx="1475619" cy="1317242"/>
+            </a:xfrm>
+          </p:grpSpPr>
+          <p:sp>
+            <p:nvSpPr>
+              <p:cNvPr id="95" name="Ellipse 94">
+                <a:extLst>
+                  <a:ext uri="{FF2B5EF4-FFF2-40B4-BE49-F238E27FC236}">
+                    <a16:creationId xmlns:a16="http://schemas.microsoft.com/office/drawing/2014/main" id="{573E6273-ECA4-2CC5-E45A-C6D8869B4500}"/>
+                  </a:ext>
+                </a:extLst>
+              </p:cNvPr>
+              <p:cNvSpPr/>
+              <p:nvPr/>
+            </p:nvSpPr>
+            <p:spPr>
+              <a:xfrm>
+                <a:off x="140304" y="258095"/>
+                <a:ext cx="1475619" cy="615719"/>
+              </a:xfrm>
+              <a:prstGeom prst="ellipse">
+                <a:avLst/>
+              </a:prstGeom>
+              <a:noFill/>
+              <a:ln w="28575" cap="flat" cmpd="sng" algn="ctr">
+                <a:solidFill>
+                  <a:schemeClr val="accent4"/>
+                </a:solidFill>
+                <a:prstDash val="solid"/>
+                <a:round/>
+                <a:headEnd type="none" w="med" len="med"/>
+                <a:tailEnd type="none" w="med" len="med"/>
+              </a:ln>
+            </p:spPr>
+            <p:style>
+              <a:lnRef idx="0">
+                <a:scrgbClr r="0" g="0" b="0"/>
+              </a:lnRef>
+              <a:fillRef idx="0">
+                <a:scrgbClr r="0" g="0" b="0"/>
+              </a:fillRef>
+              <a:effectRef idx="0">
+                <a:scrgbClr r="0" g="0" b="0"/>
+              </a:effectRef>
+              <a:fontRef idx="minor">
+                <a:schemeClr val="accent4"/>
+              </a:fontRef>
+            </p:style>
+            <p:txBody>
+              <a:bodyPr rtlCol="0" anchor="ctr"/>
+              <a:lstStyle/>
+              <a:p>
+                <a:pPr algn="ctr"/>
+                <a:endParaRPr lang="fr-FR" dirty="0"/>
+              </a:p>
+            </p:txBody>
+          </p:sp>
+          <p:cxnSp>
+            <p:nvCxnSpPr>
+              <p:cNvPr id="96" name="Connecteur droit avec flèche 95">
+                <a:extLst>
+                  <a:ext uri="{FF2B5EF4-FFF2-40B4-BE49-F238E27FC236}">
+                    <a16:creationId xmlns:a16="http://schemas.microsoft.com/office/drawing/2014/main" id="{E2679E8E-2FF4-4924-359E-524703BFFC3B}"/>
+                  </a:ext>
+                </a:extLst>
+              </p:cNvPr>
+              <p:cNvCxnSpPr/>
+              <p:nvPr/>
+            </p:nvCxnSpPr>
+            <p:spPr>
+              <a:xfrm>
+                <a:off x="895314" y="873814"/>
+                <a:ext cx="0" cy="701523"/>
+              </a:xfrm>
+              <a:prstGeom prst="straightConnector1">
+                <a:avLst/>
+              </a:prstGeom>
+              <a:ln w="28575">
+                <a:solidFill>
+                  <a:srgbClr val="0F9ED5"/>
+                </a:solidFill>
+                <a:tailEnd type="triangle"/>
+              </a:ln>
+            </p:spPr>
+            <p:style>
+              <a:lnRef idx="2">
+                <a:schemeClr val="accent1"/>
+              </a:lnRef>
+              <a:fillRef idx="0">
+                <a:schemeClr val="accent1"/>
+              </a:fillRef>
+              <a:effectRef idx="1">
+                <a:schemeClr val="accent1"/>
+              </a:effectRef>
+              <a:fontRef idx="minor">
+                <a:schemeClr val="tx1"/>
+              </a:fontRef>
+            </p:style>
+          </p:cxnSp>
+        </p:grpSp>
+        <p:sp>
+          <p:nvSpPr>
+            <p:cNvPr id="94" name="ZoneTexte 93">
+              <a:extLst>
+                <a:ext uri="{FF2B5EF4-FFF2-40B4-BE49-F238E27FC236}">
+                  <a16:creationId xmlns:a16="http://schemas.microsoft.com/office/drawing/2014/main" id="{8630F6C5-80F7-CDE2-5A67-5C0A526CA7B9}"/>
+                </a:ext>
+              </a:extLst>
+            </p:cNvPr>
+            <p:cNvSpPr txBox="1"/>
+            <p:nvPr/>
+          </p:nvSpPr>
+          <p:spPr>
+            <a:xfrm>
+              <a:off x="105587" y="1575337"/>
+              <a:ext cx="1988731" cy="588656"/>
+            </a:xfrm>
+            <a:prstGeom prst="rect">
+              <a:avLst/>
+            </a:prstGeom>
+            <a:noFill/>
+          </p:spPr>
+          <p:txBody>
+            <a:bodyPr wrap="square" rtlCol="0">
+              <a:spAutoFit/>
+            </a:bodyPr>
+            <a:lstStyle/>
+            <a:p>
+              <a:r>
+                <a:rPr lang="en-US" sz="1400" b="1" noProof="0" dirty="0">
+                  <a:solidFill>
+                    <a:srgbClr val="0F9ED5"/>
+                  </a:solidFill>
+                </a:rPr>
+                <a:t>Topic of subscription of all the agents</a:t>
+              </a:r>
+            </a:p>
+          </p:txBody>
+        </p:sp>
+      </p:grpSp>
+      <p:sp>
+        <p:nvSpPr>
+          <p:cNvPr id="120" name="Ellipse 119">
+            <a:extLst>
+              <a:ext uri="{FF2B5EF4-FFF2-40B4-BE49-F238E27FC236}">
+                <a16:creationId xmlns:a16="http://schemas.microsoft.com/office/drawing/2014/main" id="{00D65DF1-560C-1054-AF47-D0D8E97C95F4}"/>
+              </a:ext>
+            </a:extLst>
+          </p:cNvPr>
+          <p:cNvSpPr/>
+          <p:nvPr/>
+        </p:nvSpPr>
+        <p:spPr>
+          <a:xfrm flipV="1">
+            <a:off x="1666495" y="201438"/>
+            <a:ext cx="3086618" cy="1309332"/>
+          </a:xfrm>
+          <a:prstGeom prst="ellipse">
+            <a:avLst/>
+          </a:prstGeom>
+          <a:noFill/>
+          <a:ln w="28575" cap="flat" cmpd="sng" algn="ctr">
+            <a:solidFill>
+              <a:srgbClr val="C00000"/>
+            </a:solidFill>
+            <a:prstDash val="solid"/>
+            <a:round/>
+            <a:headEnd type="none" w="med" len="med"/>
+            <a:tailEnd type="none" w="med" len="med"/>
+          </a:ln>
+        </p:spPr>
+        <p:style>
+          <a:lnRef idx="0">
+            <a:scrgbClr r="0" g="0" b="0"/>
+          </a:lnRef>
+          <a:fillRef idx="0">
+            <a:scrgbClr r="0" g="0" b="0"/>
+          </a:fillRef>
+          <a:effectRef idx="0">
+            <a:scrgbClr r="0" g="0" b="0"/>
+          </a:effectRef>
+          <a:fontRef idx="minor">
+            <a:schemeClr val="accent4"/>
+          </a:fontRef>
+        </p:style>
+        <p:txBody>
+          <a:bodyPr rtlCol="0" anchor="ctr"/>
+          <a:lstStyle/>
+          <a:p>
+            <a:pPr algn="ctr"/>
+            <a:endParaRPr lang="fr-FR" dirty="0"/>
+          </a:p>
+        </p:txBody>
+      </p:sp>
+      <p:pic>
+        <p:nvPicPr>
+          <p:cNvPr id="129" name="Image 128" descr="Une image contenant Police, texte, Graphique, logo&#10;&#10;Le contenu généré par l’IA peut être incorrect.">
+            <a:extLst>
+              <a:ext uri="{FF2B5EF4-FFF2-40B4-BE49-F238E27FC236}">
+                <a16:creationId xmlns:a16="http://schemas.microsoft.com/office/drawing/2014/main" id="{65DDC9B4-A545-7FE9-DE66-4C449AA2D0D9}"/>
+              </a:ext>
+            </a:extLst>
+          </p:cNvPr>
+          <p:cNvPicPr>
+            <a:picLocks noChangeAspect="1"/>
+          </p:cNvPicPr>
+          <p:nvPr/>
+        </p:nvPicPr>
+        <p:blipFill>
+          <a:blip r:embed="rId11"/>
+          <a:stretch>
+            <a:fillRect/>
+          </a:stretch>
+        </p:blipFill>
+        <p:spPr>
+          <a:xfrm>
+            <a:off x="202008" y="2659584"/>
+            <a:ext cx="1497356" cy="444271"/>
+          </a:xfrm>
+          <a:prstGeom prst="rect">
+            <a:avLst/>
+          </a:prstGeom>
+          <a:ln>
+            <a:noFill/>
+          </a:ln>
+          <a:effectLst>
+            <a:glow rad="63500">
+              <a:srgbClr val="FFC000">
+                <a:alpha val="40000"/>
+              </a:srgbClr>
+            </a:glow>
+            <a:outerShdw blurRad="190500" algn="tl" rotWithShape="0">
+              <a:srgbClr val="000000">
+                <a:alpha val="70000"/>
+              </a:srgbClr>
+            </a:outerShdw>
+          </a:effectLst>
+        </p:spPr>
+      </p:pic>
+      <p:pic>
+        <p:nvPicPr>
+          <p:cNvPr id="131" name="Image 130" descr="Une image contenant texte, Police, logo, Graphique&#10;&#10;Le contenu généré par l’IA peut être incorrect.">
+            <a:extLst>
+              <a:ext uri="{FF2B5EF4-FFF2-40B4-BE49-F238E27FC236}">
+                <a16:creationId xmlns:a16="http://schemas.microsoft.com/office/drawing/2014/main" id="{E923D052-DCA2-A3CA-0E00-EEA792032EF9}"/>
+              </a:ext>
+            </a:extLst>
+          </p:cNvPr>
+          <p:cNvPicPr>
+            <a:picLocks noChangeAspect="1"/>
+          </p:cNvPicPr>
+          <p:nvPr/>
+        </p:nvPicPr>
+        <p:blipFill>
+          <a:blip r:embed="rId12"/>
+          <a:stretch>
+            <a:fillRect/>
+          </a:stretch>
+        </p:blipFill>
+        <p:spPr>
+          <a:xfrm>
+            <a:off x="417795" y="6032009"/>
+            <a:ext cx="954652" cy="479942"/>
+          </a:xfrm>
+          <a:prstGeom prst="rect">
+            <a:avLst/>
+          </a:prstGeom>
+          <a:ln>
+            <a:noFill/>
+          </a:ln>
+          <a:effectLst>
+            <a:glow rad="63500">
+              <a:srgbClr val="FFC000">
+                <a:alpha val="40000"/>
+              </a:srgbClr>
+            </a:glow>
+            <a:outerShdw blurRad="190500" algn="tl" rotWithShape="0">
+              <a:srgbClr val="000000">
+                <a:alpha val="70000"/>
+              </a:srgbClr>
+            </a:outerShdw>
+          </a:effectLst>
+        </p:spPr>
+      </p:pic>
+      <p:grpSp>
+        <p:nvGrpSpPr>
+          <p:cNvPr id="139" name="Groupe 138">
+            <a:extLst>
+              <a:ext uri="{FF2B5EF4-FFF2-40B4-BE49-F238E27FC236}">
+                <a16:creationId xmlns:a16="http://schemas.microsoft.com/office/drawing/2014/main" id="{A6EB14F3-E6B0-A88F-A894-9A68C4B16954}"/>
+              </a:ext>
+            </a:extLst>
+          </p:cNvPr>
+          <p:cNvGrpSpPr/>
+          <p:nvPr/>
+        </p:nvGrpSpPr>
+        <p:grpSpPr>
+          <a:xfrm>
+            <a:off x="7370953" y="80244"/>
+            <a:ext cx="4743507" cy="1435929"/>
+            <a:chOff x="7129057" y="162743"/>
+            <a:chExt cx="4604440" cy="1435929"/>
+          </a:xfrm>
+        </p:grpSpPr>
+        <p:pic>
+          <p:nvPicPr>
+            <p:cNvPr id="108" name="Image 107" descr="Une image contenant texte, capture d’écran, Police, logo&#10;&#10;Le contenu généré par l’IA peut être incorrect.">
+              <a:extLst>
+                <a:ext uri="{FF2B5EF4-FFF2-40B4-BE49-F238E27FC236}">
+                  <a16:creationId xmlns:a16="http://schemas.microsoft.com/office/drawing/2014/main" id="{277EFE6B-1F0F-C5AA-BEC1-F00716224F02}"/>
+                </a:ext>
+              </a:extLst>
+            </p:cNvPr>
+            <p:cNvPicPr>
+              <a:picLocks noChangeAspect="1"/>
+            </p:cNvPicPr>
+            <p:nvPr/>
+          </p:nvPicPr>
+          <p:blipFill>
+            <a:blip r:embed="rId13"/>
+            <a:stretch>
+              <a:fillRect/>
+            </a:stretch>
+          </p:blipFill>
+          <p:spPr>
+            <a:xfrm>
+              <a:off x="7129057" y="162743"/>
+              <a:ext cx="2012324" cy="1435929"/>
+            </a:xfrm>
+            <a:prstGeom prst="rect">
+              <a:avLst/>
+            </a:prstGeom>
+            <a:ln>
+              <a:noFill/>
+            </a:ln>
+            <a:effectLst>
+              <a:glow rad="63500">
+                <a:srgbClr val="C00000">
+                  <a:alpha val="40000"/>
+                </a:srgbClr>
+              </a:glow>
+              <a:outerShdw blurRad="190500" algn="tl" rotWithShape="0">
+                <a:srgbClr val="000000">
+                  <a:alpha val="70000"/>
+                </a:srgbClr>
+              </a:outerShdw>
+            </a:effectLst>
+          </p:spPr>
+        </p:pic>
+        <p:pic>
+          <p:nvPicPr>
+            <p:cNvPr id="136" name="Image 135" descr="Une image contenant texte, Police, capture d’écran, noir&#10;&#10;Le contenu généré par l’IA peut être incorrect.">
+              <a:extLst>
+                <a:ext uri="{FF2B5EF4-FFF2-40B4-BE49-F238E27FC236}">
+                  <a16:creationId xmlns:a16="http://schemas.microsoft.com/office/drawing/2014/main" id="{85CC6BEC-F1C5-FF3E-A87E-6DEFF311B2A8}"/>
+                </a:ext>
+              </a:extLst>
+            </p:cNvPr>
+            <p:cNvPicPr>
+              <a:picLocks noChangeAspect="1"/>
+            </p:cNvPicPr>
+            <p:nvPr/>
+          </p:nvPicPr>
+          <p:blipFill>
+            <a:blip r:embed="rId14"/>
+            <a:stretch>
+              <a:fillRect/>
+            </a:stretch>
+          </p:blipFill>
+          <p:spPr>
+            <a:xfrm>
+              <a:off x="8815360" y="465777"/>
+              <a:ext cx="2918137" cy="656662"/>
+            </a:xfrm>
+            <a:prstGeom prst="rect">
+              <a:avLst/>
+            </a:prstGeom>
+            <a:ln>
+              <a:noFill/>
+            </a:ln>
+            <a:effectLst>
+              <a:glow rad="63500">
+                <a:srgbClr val="C00000">
+                  <a:alpha val="40000"/>
+                </a:srgbClr>
+              </a:glow>
+              <a:outerShdw blurRad="190500" algn="tl" rotWithShape="0">
+                <a:srgbClr val="000000">
+                  <a:alpha val="70000"/>
+                </a:srgbClr>
+              </a:outerShdw>
+            </a:effectLst>
+          </p:spPr>
+        </p:pic>
+      </p:grpSp>
+      <p:sp>
+        <p:nvSpPr>
+          <p:cNvPr id="67" name="ZoneTexte 66">
+            <a:extLst>
+              <a:ext uri="{FF2B5EF4-FFF2-40B4-BE49-F238E27FC236}">
+                <a16:creationId xmlns:a16="http://schemas.microsoft.com/office/drawing/2014/main" id="{990692D8-0FFB-4E10-8533-06CE9B4A84C4}"/>
+              </a:ext>
+            </a:extLst>
+          </p:cNvPr>
+          <p:cNvSpPr txBox="1"/>
+          <p:nvPr/>
+        </p:nvSpPr>
+        <p:spPr>
+          <a:xfrm>
+            <a:off x="5786945" y="499937"/>
+            <a:ext cx="1785233" cy="369332"/>
+          </a:xfrm>
+          <a:prstGeom prst="rect">
+            <a:avLst/>
+          </a:prstGeom>
+          <a:noFill/>
+        </p:spPr>
+        <p:txBody>
+          <a:bodyPr wrap="square" rtlCol="0">
+            <a:spAutoFit/>
+          </a:bodyPr>
+          <a:lstStyle/>
+          <a:p>
+            <a:r>
+              <a:rPr lang="en-US" b="1" noProof="0" dirty="0">
+                <a:solidFill>
+                  <a:srgbClr val="C00000"/>
+                </a:solidFill>
+              </a:rPr>
+              <a:t>Encapsulates</a:t>
+            </a:r>
+          </a:p>
+        </p:txBody>
+      </p:sp>
+      <p:cxnSp>
+        <p:nvCxnSpPr>
+          <p:cNvPr id="53" name="Connecteur droit avec flèche 52">
+            <a:extLst>
+              <a:ext uri="{FF2B5EF4-FFF2-40B4-BE49-F238E27FC236}">
+                <a16:creationId xmlns:a16="http://schemas.microsoft.com/office/drawing/2014/main" id="{FC5F5521-09FD-8909-283F-5EBB9C9E718A}"/>
+              </a:ext>
+            </a:extLst>
+          </p:cNvPr>
+          <p:cNvCxnSpPr>
+            <a:cxnSpLocks/>
+          </p:cNvCxnSpPr>
+          <p:nvPr/>
+        </p:nvCxnSpPr>
+        <p:spPr>
+          <a:xfrm>
+            <a:off x="3239105" y="1281097"/>
+            <a:ext cx="528269" cy="486555"/>
+          </a:xfrm>
+          <a:prstGeom prst="straightConnector1">
+            <a:avLst/>
+          </a:prstGeom>
+          <a:ln w="28575">
+            <a:solidFill>
+              <a:srgbClr val="0F9ED5"/>
+            </a:solidFill>
+            <a:tailEnd type="triangle"/>
+          </a:ln>
+        </p:spPr>
+        <p:style>
+          <a:lnRef idx="2">
+            <a:schemeClr val="accent1"/>
+          </a:lnRef>
+          <a:fillRef idx="0">
+            <a:schemeClr val="accent1"/>
+          </a:fillRef>
+          <a:effectRef idx="1">
+            <a:schemeClr val="accent1"/>
+          </a:effectRef>
+          <a:fontRef idx="minor">
+            <a:schemeClr val="tx1"/>
+          </a:fontRef>
+        </p:style>
+      </p:cxnSp>
+      <p:cxnSp>
+        <p:nvCxnSpPr>
+          <p:cNvPr id="56" name="Connecteur droit avec flèche 55">
+            <a:extLst>
+              <a:ext uri="{FF2B5EF4-FFF2-40B4-BE49-F238E27FC236}">
+                <a16:creationId xmlns:a16="http://schemas.microsoft.com/office/drawing/2014/main" id="{50D72F8C-E90A-D9A8-E214-75BDC4730189}"/>
+              </a:ext>
+            </a:extLst>
+          </p:cNvPr>
+          <p:cNvCxnSpPr>
+            <a:cxnSpLocks/>
+            <a:stCxn id="47" idx="0"/>
+            <a:endCxn id="43" idx="1"/>
+          </p:cNvCxnSpPr>
+          <p:nvPr/>
+        </p:nvCxnSpPr>
+        <p:spPr>
+          <a:xfrm>
+            <a:off x="3239106" y="1299672"/>
+            <a:ext cx="1471458" cy="777396"/>
+          </a:xfrm>
+          <a:prstGeom prst="straightConnector1">
+            <a:avLst/>
+          </a:prstGeom>
+          <a:ln w="28575">
+            <a:solidFill>
+              <a:srgbClr val="0F9ED5"/>
+            </a:solidFill>
+            <a:tailEnd type="triangle"/>
+          </a:ln>
+        </p:spPr>
+        <p:style>
+          <a:lnRef idx="2">
+            <a:schemeClr val="accent1"/>
+          </a:lnRef>
+          <a:fillRef idx="0">
+            <a:schemeClr val="accent1"/>
+          </a:fillRef>
+          <a:effectRef idx="1">
+            <a:schemeClr val="accent1"/>
+          </a:effectRef>
+          <a:fontRef idx="minor">
+            <a:schemeClr val="tx1"/>
+          </a:fontRef>
+        </p:style>
+      </p:cxnSp>
+      <p:cxnSp>
+        <p:nvCxnSpPr>
+          <p:cNvPr id="72" name="Connecteur droit avec flèche 71">
+            <a:extLst>
+              <a:ext uri="{FF2B5EF4-FFF2-40B4-BE49-F238E27FC236}">
+                <a16:creationId xmlns:a16="http://schemas.microsoft.com/office/drawing/2014/main" id="{D6FEBFD6-0AAB-CA00-559A-179F656E25BC}"/>
+              </a:ext>
+            </a:extLst>
+          </p:cNvPr>
+          <p:cNvCxnSpPr>
+            <a:cxnSpLocks/>
+            <a:stCxn id="75" idx="2"/>
+            <a:endCxn id="62" idx="7"/>
+          </p:cNvCxnSpPr>
+          <p:nvPr/>
+        </p:nvCxnSpPr>
+        <p:spPr>
+          <a:xfrm flipH="1" flipV="1">
+            <a:off x="4187517" y="1260971"/>
+            <a:ext cx="3975324" cy="1752031"/>
+          </a:xfrm>
+          <a:prstGeom prst="straightConnector1">
+            <a:avLst/>
+          </a:prstGeom>
+          <a:ln w="28575">
+            <a:solidFill>
+              <a:srgbClr val="FFC000"/>
+            </a:solidFill>
+            <a:tailEnd type="triangle"/>
+          </a:ln>
+        </p:spPr>
+        <p:style>
+          <a:lnRef idx="2">
+            <a:schemeClr val="accent1"/>
+          </a:lnRef>
+          <a:fillRef idx="0">
+            <a:schemeClr val="accent1"/>
+          </a:fillRef>
+          <a:effectRef idx="1">
+            <a:schemeClr val="accent1"/>
+          </a:effectRef>
+          <a:fontRef idx="minor">
+            <a:schemeClr val="tx1"/>
+          </a:fontRef>
+        </p:style>
+      </p:cxnSp>
+    </p:spTree>
+    <p:extLst>
+      <p:ext uri="{BB962C8B-B14F-4D97-AF65-F5344CB8AC3E}">
+        <p14:creationId xmlns:p14="http://schemas.microsoft.com/office/powerpoint/2010/main" val="3691898343"/>
       </p:ext>
     </p:extLst>
   </p:cSld>
@@ -6642,4 +8990,319 @@
     </a:ext>
   </a:extLst>
 </a:theme>
+</file>
+
+<file path=ppt/theme/theme2.xml><?xml version="1.0" encoding="utf-8"?>
+<a:theme xmlns:a="http://schemas.openxmlformats.org/drawingml/2006/main" name="Thème Office">
+  <a:themeElements>
+    <a:clrScheme name="Office">
+      <a:dk1>
+        <a:sysClr val="windowText" lastClr="000000"/>
+      </a:dk1>
+      <a:lt1>
+        <a:sysClr val="window" lastClr="FFFFFF"/>
+      </a:lt1>
+      <a:dk2>
+        <a:srgbClr val="0E2841"/>
+      </a:dk2>
+      <a:lt2>
+        <a:srgbClr val="E8E8E8"/>
+      </a:lt2>
+      <a:accent1>
+        <a:srgbClr val="156082"/>
+      </a:accent1>
+      <a:accent2>
+        <a:srgbClr val="E97132"/>
+      </a:accent2>
+      <a:accent3>
+        <a:srgbClr val="196B24"/>
+      </a:accent3>
+      <a:accent4>
+        <a:srgbClr val="0F9ED5"/>
+      </a:accent4>
+      <a:accent5>
+        <a:srgbClr val="A02B93"/>
+      </a:accent5>
+      <a:accent6>
+        <a:srgbClr val="4EA72E"/>
+      </a:accent6>
+      <a:hlink>
+        <a:srgbClr val="467886"/>
+      </a:hlink>
+      <a:folHlink>
+        <a:srgbClr val="96607D"/>
+      </a:folHlink>
+    </a:clrScheme>
+    <a:fontScheme name="Office">
+      <a:majorFont>
+        <a:latin typeface="Aptos Display" panose="02110004020202020204"/>
+        <a:ea typeface=""/>
+        <a:cs typeface=""/>
+        <a:font script="Jpan" typeface="游ゴシック Light"/>
+        <a:font script="Hang" typeface="맑은 고딕"/>
+        <a:font script="Hans" typeface="等线 Light"/>
+        <a:font script="Hant" typeface="新細明體"/>
+        <a:font script="Arab" typeface="Times New Roman"/>
+        <a:font script="Hebr" typeface="Times New Roman"/>
+        <a:font script="Thai" typeface="Angsana New"/>
+        <a:font script="Ethi" typeface="Nyala"/>
+        <a:font script="Beng" typeface="Vrinda"/>
+        <a:font script="Gujr" typeface="Shruti"/>
+        <a:font script="Khmr" typeface="MoolBoran"/>
+        <a:font script="Knda" typeface="Tunga"/>
+        <a:font script="Guru" typeface="Raavi"/>
+        <a:font script="Cans" typeface="Euphemia"/>
+        <a:font script="Cher" typeface="Plantagenet Cherokee"/>
+        <a:font script="Yiii" typeface="Microsoft Yi Baiti"/>
+        <a:font script="Tibt" typeface="Microsoft Himalaya"/>
+        <a:font script="Thaa" typeface="MV Boli"/>
+        <a:font script="Deva" typeface="Mangal"/>
+        <a:font script="Telu" typeface="Gautami"/>
+        <a:font script="Taml" typeface="Latha"/>
+        <a:font script="Syrc" typeface="Estrangelo Edessa"/>
+        <a:font script="Orya" typeface="Kalinga"/>
+        <a:font script="Mlym" typeface="Kartika"/>
+        <a:font script="Laoo" typeface="DokChampa"/>
+        <a:font script="Sinh" typeface="Iskoola Pota"/>
+        <a:font script="Mong" typeface="Mongolian Baiti"/>
+        <a:font script="Viet" typeface="Times New Roman"/>
+        <a:font script="Uigh" typeface="Microsoft Uighur"/>
+        <a:font script="Geor" typeface="Sylfaen"/>
+        <a:font script="Armn" typeface="Arial"/>
+        <a:font script="Bugi" typeface="Leelawadee UI"/>
+        <a:font script="Bopo" typeface="Microsoft JhengHei"/>
+        <a:font script="Java" typeface="Javanese Text"/>
+        <a:font script="Lisu" typeface="Segoe UI"/>
+        <a:font script="Mymr" typeface="Myanmar Text"/>
+        <a:font script="Nkoo" typeface="Ebrima"/>
+        <a:font script="Olck" typeface="Nirmala UI"/>
+        <a:font script="Osma" typeface="Ebrima"/>
+        <a:font script="Phag" typeface="Phagspa"/>
+        <a:font script="Syrn" typeface="Estrangelo Edessa"/>
+        <a:font script="Syrj" typeface="Estrangelo Edessa"/>
+        <a:font script="Syre" typeface="Estrangelo Edessa"/>
+        <a:font script="Sora" typeface="Nirmala UI"/>
+        <a:font script="Tale" typeface="Microsoft Tai Le"/>
+        <a:font script="Talu" typeface="Microsoft New Tai Lue"/>
+        <a:font script="Tfng" typeface="Ebrima"/>
+      </a:majorFont>
+      <a:minorFont>
+        <a:latin typeface="Aptos" panose="02110004020202020204"/>
+        <a:ea typeface=""/>
+        <a:cs typeface=""/>
+        <a:font script="Jpan" typeface="游ゴシック"/>
+        <a:font script="Hang" typeface="맑은 고딕"/>
+        <a:font script="Hans" typeface="等线"/>
+        <a:font script="Hant" typeface="新細明體"/>
+        <a:font script="Arab" typeface="Arial"/>
+        <a:font script="Hebr" typeface="Arial"/>
+        <a:font script="Thai" typeface="Cordia New"/>
+        <a:font script="Ethi" typeface="Nyala"/>
+        <a:font script="Beng" typeface="Vrinda"/>
+        <a:font script="Gujr" typeface="Shruti"/>
+        <a:font script="Khmr" typeface="DaunPenh"/>
+        <a:font script="Knda" typeface="Tunga"/>
+        <a:font script="Guru" typeface="Raavi"/>
+        <a:font script="Cans" typeface="Euphemia"/>
+        <a:font script="Cher" typeface="Plantagenet Cherokee"/>
+        <a:font script="Yiii" typeface="Microsoft Yi Baiti"/>
+        <a:font script="Tibt" typeface="Microsoft Himalaya"/>
+        <a:font script="Thaa" typeface="MV Boli"/>
+        <a:font script="Deva" typeface="Mangal"/>
+        <a:font script="Telu" typeface="Gautami"/>
+        <a:font script="Taml" typeface="Latha"/>
+        <a:font script="Syrc" typeface="Estrangelo Edessa"/>
+        <a:font script="Orya" typeface="Kalinga"/>
+        <a:font script="Mlym" typeface="Kartika"/>
+        <a:font script="Laoo" typeface="DokChampa"/>
+        <a:font script="Sinh" typeface="Iskoola Pota"/>
+        <a:font script="Mong" typeface="Mongolian Baiti"/>
+        <a:font script="Viet" typeface="Arial"/>
+        <a:font script="Uigh" typeface="Microsoft Uighur"/>
+        <a:font script="Geor" typeface="Sylfaen"/>
+        <a:font script="Armn" typeface="Arial"/>
+        <a:font script="Bugi" typeface="Leelawadee UI"/>
+        <a:font script="Bopo" typeface="Microsoft JhengHei"/>
+        <a:font script="Java" typeface="Javanese Text"/>
+        <a:font script="Lisu" typeface="Segoe UI"/>
+        <a:font script="Mymr" typeface="Myanmar Text"/>
+        <a:font script="Nkoo" typeface="Ebrima"/>
+        <a:font script="Olck" typeface="Nirmala UI"/>
+        <a:font script="Osma" typeface="Ebrima"/>
+        <a:font script="Phag" typeface="Phagspa"/>
+        <a:font script="Syrn" typeface="Estrangelo Edessa"/>
+        <a:font script="Syrj" typeface="Estrangelo Edessa"/>
+        <a:font script="Syre" typeface="Estrangelo Edessa"/>
+        <a:font script="Sora" typeface="Nirmala UI"/>
+        <a:font script="Tale" typeface="Microsoft Tai Le"/>
+        <a:font script="Talu" typeface="Microsoft New Tai Lue"/>
+        <a:font script="Tfng" typeface="Ebrima"/>
+      </a:minorFont>
+    </a:fontScheme>
+    <a:fmtScheme name="Office">
+      <a:fillStyleLst>
+        <a:solidFill>
+          <a:schemeClr val="phClr"/>
+        </a:solidFill>
+        <a:gradFill rotWithShape="1">
+          <a:gsLst>
+            <a:gs pos="0">
+              <a:schemeClr val="phClr">
+                <a:lumMod val="110000"/>
+                <a:satMod val="105000"/>
+                <a:tint val="67000"/>
+              </a:schemeClr>
+            </a:gs>
+            <a:gs pos="50000">
+              <a:schemeClr val="phClr">
+                <a:lumMod val="105000"/>
+                <a:satMod val="103000"/>
+                <a:tint val="73000"/>
+              </a:schemeClr>
+            </a:gs>
+            <a:gs pos="100000">
+              <a:schemeClr val="phClr">
+                <a:lumMod val="105000"/>
+                <a:satMod val="109000"/>
+                <a:tint val="81000"/>
+              </a:schemeClr>
+            </a:gs>
+          </a:gsLst>
+          <a:lin ang="5400000" scaled="0"/>
+        </a:gradFill>
+        <a:gradFill rotWithShape="1">
+          <a:gsLst>
+            <a:gs pos="0">
+              <a:schemeClr val="phClr">
+                <a:satMod val="103000"/>
+                <a:lumMod val="102000"/>
+                <a:tint val="94000"/>
+              </a:schemeClr>
+            </a:gs>
+            <a:gs pos="50000">
+              <a:schemeClr val="phClr">
+                <a:satMod val="110000"/>
+                <a:lumMod val="100000"/>
+                <a:shade val="100000"/>
+              </a:schemeClr>
+            </a:gs>
+            <a:gs pos="100000">
+              <a:schemeClr val="phClr">
+                <a:lumMod val="99000"/>
+                <a:satMod val="120000"/>
+                <a:shade val="78000"/>
+              </a:schemeClr>
+            </a:gs>
+          </a:gsLst>
+          <a:lin ang="5400000" scaled="0"/>
+        </a:gradFill>
+      </a:fillStyleLst>
+      <a:lnStyleLst>
+        <a:ln w="12700" cap="flat" cmpd="sng" algn="ctr">
+          <a:solidFill>
+            <a:schemeClr val="phClr"/>
+          </a:solidFill>
+          <a:prstDash val="solid"/>
+          <a:miter lim="800000"/>
+        </a:ln>
+        <a:ln w="19050" cap="flat" cmpd="sng" algn="ctr">
+          <a:solidFill>
+            <a:schemeClr val="phClr"/>
+          </a:solidFill>
+          <a:prstDash val="solid"/>
+          <a:miter lim="800000"/>
+        </a:ln>
+        <a:ln w="25400" cap="flat" cmpd="sng" algn="ctr">
+          <a:solidFill>
+            <a:schemeClr val="phClr"/>
+          </a:solidFill>
+          <a:prstDash val="solid"/>
+          <a:miter lim="800000"/>
+        </a:ln>
+      </a:lnStyleLst>
+      <a:effectStyleLst>
+        <a:effectStyle>
+          <a:effectLst/>
+        </a:effectStyle>
+        <a:effectStyle>
+          <a:effectLst/>
+        </a:effectStyle>
+        <a:effectStyle>
+          <a:effectLst>
+            <a:outerShdw blurRad="57150" dist="19050" dir="5400000" algn="ctr" rotWithShape="0">
+              <a:srgbClr val="000000">
+                <a:alpha val="63000"/>
+              </a:srgbClr>
+            </a:outerShdw>
+          </a:effectLst>
+        </a:effectStyle>
+      </a:effectStyleLst>
+      <a:bgFillStyleLst>
+        <a:solidFill>
+          <a:schemeClr val="phClr"/>
+        </a:solidFill>
+        <a:solidFill>
+          <a:schemeClr val="phClr">
+            <a:tint val="95000"/>
+            <a:satMod val="170000"/>
+          </a:schemeClr>
+        </a:solidFill>
+        <a:gradFill rotWithShape="1">
+          <a:gsLst>
+            <a:gs pos="0">
+              <a:schemeClr val="phClr">
+                <a:tint val="93000"/>
+                <a:satMod val="150000"/>
+                <a:shade val="98000"/>
+                <a:lumMod val="102000"/>
+              </a:schemeClr>
+            </a:gs>
+            <a:gs pos="50000">
+              <a:schemeClr val="phClr">
+                <a:tint val="98000"/>
+                <a:satMod val="130000"/>
+                <a:shade val="90000"/>
+                <a:lumMod val="103000"/>
+              </a:schemeClr>
+            </a:gs>
+            <a:gs pos="100000">
+              <a:schemeClr val="phClr">
+                <a:shade val="63000"/>
+                <a:satMod val="120000"/>
+              </a:schemeClr>
+            </a:gs>
+          </a:gsLst>
+          <a:lin ang="5400000" scaled="0"/>
+        </a:gradFill>
+      </a:bgFillStyleLst>
+    </a:fmtScheme>
+  </a:themeElements>
+  <a:objectDefaults>
+    <a:lnDef>
+      <a:spPr/>
+      <a:bodyPr/>
+      <a:lstStyle/>
+      <a:style>
+        <a:lnRef idx="2">
+          <a:schemeClr val="accent1"/>
+        </a:lnRef>
+        <a:fillRef idx="0">
+          <a:schemeClr val="accent1"/>
+        </a:fillRef>
+        <a:effectRef idx="1">
+          <a:schemeClr val="accent1"/>
+        </a:effectRef>
+        <a:fontRef idx="minor">
+          <a:schemeClr val="tx1"/>
+        </a:fontRef>
+      </a:style>
+    </a:lnDef>
+  </a:objectDefaults>
+  <a:extraClrSchemeLst/>
+  <a:extLst>
+    <a:ext uri="{05A4C25C-085E-4340-85A3-A5531E510DB2}">
+      <thm15:themeFamily xmlns:thm15="http://schemas.microsoft.com/office/thememl/2012/main" name="Office Theme" id="{2E142A2C-CD16-42D6-873A-C26D2A0506FA}" vid="{1BDDFF52-6CD6-40A5-AB3C-68EB2F1E4D0A}"/>
+    </a:ext>
+  </a:extLst>
+</a:theme>
 </file>
</xml_diff>